<commit_message>
Add WSL 2 comparison slide to desktop coding agents deck
Adds a slide contrasting Claude Desktop's WSL session plus bubblewrap/socat
sandbox with OpenCode Desktop's WSL server mode, which has no sandbox
inside the distro. Updates the OpenCode cells in the sandboxing table,
the OpenCode overview, and the recommendations accordingly.

Co-Authored-By: Claude Fable 5.1 <noreply@anthropic.com>
Claude-Session: https://claude.ai/code/session_01LiMNUZYkauY1GeK91s8ze9
</commit_message>
<xml_diff>
--- a/docs/presentations/desktop-coding-agents-sandboxing-comparison.pptx
+++ b/docs/presentations/desktop-coding-agents-sandboxing-comparison.pptx
@@ -14,9 +14,10 @@
     <p:sldId id="262" r:id="rId8"/>
     <p:sldId id="263" r:id="rId9"/>
     <p:sldId id="264" r:id="rId10"/>
+    <p:sldId id="265" r:id="rId11"/>
   </p:sldIdLst>
   <p:notesMasterIdLst>
-    <p:notesMasterId r:id="rId11"/>
+    <p:notesMasterId r:id="rId12"/>
   </p:notesMasterIdLst>
   <p:sldSz cx="9144000" cy="5143500"/>
   <p:notesSz cx="5143500" cy="9144000"/>
@@ -554,6 +555,98 @@
 </p:notes>
 </file>
 
+<file path=ppt/notesSlides/notesSlide10.xml><?xml version="1.0" encoding="utf-8"?>
+<p:notes xmlns:a="http://schemas.openxmlformats.org/drawingml/2006/main" xmlns:r="http://schemas.openxmlformats.org/officeDocument/2006/relationships" xmlns:p="http://schemas.openxmlformats.org/presentationml/2006/main">
+  <p:cSld>
+    <p:spTree>
+      <p:nvGrpSpPr>
+        <p:cNvPr id="1" name=""/>
+        <p:cNvGrpSpPr/>
+        <p:nvPr/>
+      </p:nvGrpSpPr>
+      <p:grpSpPr>
+        <a:xfrm>
+          <a:off x="0" y="0"/>
+          <a:ext cx="0" cy="0"/>
+          <a:chOff x="0" y="0"/>
+          <a:chExt cx="0" cy="0"/>
+        </a:xfrm>
+      </p:grpSpPr>
+      <p:sp>
+        <p:nvSpPr>
+          <p:cNvPr id="2" name="Slide Image Placeholder 1"/>
+          <p:cNvSpPr>
+            <a:spLocks noGrp="1" noRot="1" noChangeAspect="1"/>
+          </p:cNvSpPr>
+          <p:nvPr>
+            <p:ph type="sldImg"/>
+          </p:nvPr>
+        </p:nvSpPr>
+        <p:spPr/>
+      </p:sp>
+      <p:sp>
+        <p:nvSpPr>
+          <p:cNvPr id="3" name="Notes Placeholder 2"/>
+          <p:cNvSpPr>
+            <a:spLocks noGrp="1"/>
+          </p:cNvSpPr>
+          <p:nvPr>
+            <p:ph type="body" idx="1"/>
+          </p:nvPr>
+        </p:nvSpPr>
+        <p:spPr/>
+        <p:txBody>
+          <a:bodyPr/>
+          <a:lstStyle/>
+          <a:p>
+            <a:r>
+              <a:rPr lang="en-US" dirty="0"/>
+              <a:t>My recommendations for Windows.
+Claude Desktop: start sessions in the WSL environment and enable the sandbox once. Untrusted repos go to a Cloud session. Never enable Bypass on the host.
+Codex: install the elevated Windows sandbox or run under WSL 2. Stay in Auto, and treat each "run outside the sandbox" approval as handing over full access.
+OpenCode: the app has no wall, so put it in one: Docker Sandboxes, a dev container or a VM. Then set bash and edit to ask and disable sharing.
+For all three: commit first, keep backups off the machine, and never point an agent at your home directory. Thank you.</a:t>
+            </a:r>
+            <a:endParaRPr lang="en-US" dirty="0"/>
+          </a:p>
+        </p:txBody>
+      </p:sp>
+      <p:sp>
+        <p:nvSpPr>
+          <p:cNvPr id="4" name="Slide Number Placeholder 3"/>
+          <p:cNvSpPr>
+            <a:spLocks noGrp="1"/>
+          </p:cNvSpPr>
+          <p:nvPr>
+            <p:ph type="sldNum" sz="quarter" idx="10"/>
+          </p:nvPr>
+        </p:nvSpPr>
+        <p:spPr/>
+        <p:txBody>
+          <a:bodyPr/>
+          <a:lstStyle/>
+          <a:p>
+            <a:fld id="{F7021451-1387-4CA6-816F-3879F97B5CBC}" type="slidenum">
+              <a:rPr lang="en-US"/>
+              <a:t>10</a:t>
+            </a:fld>
+            <a:endParaRPr lang="en-US"/>
+          </a:p>
+        </p:txBody>
+      </p:sp>
+    </p:spTree>
+    <p:extLst>
+      <p:ext uri="{BB962C8B-B14F-4D97-AF65-F5344CB8AC3E}">
+        <p14:creationId xmlns:p14="http://schemas.microsoft.com/office/powerpoint/2010/main" val="1024086991"/>
+      </p:ext>
+    </p:extLst>
+  </p:cSld>
+  <p:clrMapOvr>
+    <a:masterClrMapping/>
+  </p:clrMapOvr>
+</p:notes>
+</file>
+
 <file path=ppt/notesSlides/notesSlide2.xml><?xml version="1.0" encoding="utf-8"?>
 <p:notes xmlns:a="http://schemas.openxmlformats.org/drawingml/2006/main" xmlns:r="http://schemas.openxmlformats.org/officeDocument/2006/relationships" xmlns:p="http://schemas.openxmlformats.org/presentationml/2006/main">
   <p:cSld>
@@ -600,8 +693,8 @@
           <a:p>
             <a:r>
               <a:rPr lang="en-US" dirty="0"/>
-              <a:t>One framing first. An agent started in a repository runs a shell with your user rights. The folder itself is not a wall.
-There are three kinds of protection. The policy layer lives inside the agent: prompts, allow and deny lists, and in Claude's case a classifier. It reads the command text, so an approved command or a script can slip through.
+              <a:t>One framing first. An agent in a repository runs a shell with your user rights. The folder is not a wall.
+Three kinds of protection. The policy layer lives inside the agent: prompts, allow and deny lists, and in Claude's case a classifier. It reads the command text, so an approved command or a script can slip through.
 The OS layer uses the kernel, which refuses the write whatever the command says.
 The isolation layer is a VM, container or cloud session.
 All three have the first layer. They differ on the other two.</a:t>
@@ -692,9 +785,9 @@
           <a:p>
             <a:r>
               <a:rPr lang="en-US" dirty="0"/>
-              <a:t>Claude Desktop first. Your instinct is right: a Local session on Windows uses Git Bash running as you, and Anthropic's own setup table says sandboxing is not supported on native Windows, only in WSL 2.
+              <a:t>Claude Desktop first. A Local session on Windows uses Git Bash running as you, and Anthropic's setup table says sandboxing is not supported on native Windows, only in WSL 2.
 The policy layer is the strongest of the three. Manual mode writes only inside the project. Auto mode has a second model review every command and block things like rm -rf on home or curl piped to bash. Deleting root, home or the project's parent always prompts.
-But once approved, Git Bash does what it says. For real enforcement on Windows, use the WSL environment with the sandbox on, or a Cloud session.</a:t>
+But once approved, Git Bash does what it says. For real enforcement, use the WSL environment with the sandbox on, or a Cloud session.</a:t>
             </a:r>
             <a:endParaRPr lang="en-US" dirty="0"/>
           </a:p>
@@ -783,7 +876,7 @@
             <a:r>
               <a:rPr lang="en-US" dirty="0"/>
               <a:t>Codex, now a mode in the ChatGPT desktop app, takes the opposite approach: the sandbox is kernel-enforced on all platforms.
-macOS uses Seatbelt, Linux and WSL use bubblewrap and seccomp with no network, and it is the only one with a native Windows sandbox, based on restricted tokens, ACLs and firewall rules.
+macOS uses Seatbelt, Linux and WSL use bubblewrap and seccomp, and it is the only one with a native Windows sandbox, based on restricted tokens, ACLs and firewall rules.
 The default for a trusted folder is Auto: write only inside the workspace, network off. When a command hits the wall, Codex asks to rerun it outside the sandbox. That approval is where protection ends.
 The Windows sandbox is alpha, and the serious deletion reports all involved Full access mode.</a:t>
             </a:r>
@@ -875,7 +968,7 @@
               <a:rPr lang="en-US" dirty="0"/>
               <a:t>OpenCode Desktop is an Electron front end over the same runtime as the terminal version. The source shows the shell tool spawning your command directly. There is no sandbox wrapper on any platform. On Windows it prefers PowerShell, then Git Bash.
 The defaults are the most permissive: bash, edit and web fetch run without prompts. Only leaving the project directory prompts, and approving it opens the whole parent folder. Per-pattern rules can tighten this, but that is on you.
-The upside: open source, auditable, local models. The maintainers' answer to sandboxing is containers.</a:t>
+The upside: open source, auditable, local models, and the server can run in WSL or a container, which the next slide covers.</a:t>
             </a:r>
             <a:endParaRPr lang="en-US" dirty="0"/>
           </a:p>
@@ -963,11 +1056,9 @@
           <a:p>
             <a:r>
               <a:rPr lang="en-US" dirty="0"/>
-              <a:t>The sandboxing picture in one table.
-On macOS and Linux, Claude Code and Codex both have kernel sandboxes. Codex is on by default; Claude Code needs the sandbox command once.
-On native Windows, only Codex has one, and it is alpha. Claude Desktop on Windows relies on policy unless you pick WSL or Cloud. OpenCode has none anywhere.
-Network: Codex cuts it inside the sandbox. Claude routes through an allowlist proxy that prompts per domain. OpenCode allows it by default.
-Every product has an escape hatch; in OpenCode there is no wall to escape from.</a:t>
+              <a:t>Can I do with OpenCode what I do with Claude, and run the agent inside Ubuntu on WSL 2?
+Half of it, yes. OpenCode Desktop has a built-in WSL mode: it starts its server inside the distro and the app talks to it over HTTP. It can also attach to any server you run yourself, in a container or behind an SSH port forward.
+The other half, no. Inside the distro Claude Code uses bubblewrap and socat to enforce its sandbox. OpenCode has no such code, so WSL alone changes where commands run, not what they may touch. For a real wall, run its server in Docker Sandboxes or a container and connect the GUI to it.</a:t>
             </a:r>
             <a:endParaRPr lang="en-US" dirty="0"/>
           </a:p>
@@ -1055,12 +1146,11 @@
           <a:p>
             <a:r>
               <a:rPr lang="en-US" dirty="0"/>
-              <a:t>Sandboxing is not the whole story.
-Default posture: Claude starts in Auto with a classifier. Codex starts an untrusted folder read-only. OpenCode starts with almost everything allowed.
-Destructive-command guards: Claude has explicit ones, Codex relies on the sandbox, OpenCode has only what you configure.
-Prompt injection: Claude isolates web content and its classifier watches for hostile instructions. Codex cuts the network. OpenCode documents nothing specific.
-OpenCode's share command uploads whole sessions to a public link; disable it at work.
-Only Claude and Codex offer managed enterprise policy.</a:t>
+              <a:t>The sandboxing picture in one table.
+On macOS and Linux, Claude Code and Codex both have kernel sandboxes. Codex is on by default; Claude Code needs the sandbox command once.
+On native Windows, only Codex has one, and it is alpha. OpenCode has none anywhere.
+Network: Codex cuts it inside the sandbox, Claude routes through an allowlist proxy, OpenCode allows it by default.
+Every product has an escape hatch; in OpenCode there is no wall to escape from.</a:t>
             </a:r>
             <a:endParaRPr lang="en-US" dirty="0"/>
           </a:p>
@@ -1148,11 +1238,12 @@
           <a:p>
             <a:r>
               <a:rPr lang="en-US" dirty="0"/>
-              <a:t>None of this is theoretical. All three have public reports of deletions outside the repository.
-Claude Code: a cleanup command with a stray tilde removed a Mac home directory, and Windows reports include Git Bash deleting across the C drive. The policy saw the command; the shell expanded the path afterwards.
-Codex: the severe Windows case deleted ten workspace roots and Program Files folders, in Full access with approvals off. No verified escape of the sandbox itself.
-OpenCode: a June 2026 report describes an entire drive cleared. There was only a prompt.
-A prompt is not a boundary. The kernel or a VM is.</a:t>
+              <a:t>Sandboxing is not the whole story.
+Defaults: Claude starts in Auto with a classifier, Codex starts an untrusted folder read-only, OpenCode starts with almost everything allowed.
+Destructive-command guards: Claude has explicit ones, Codex relies on the sandbox, OpenCode has only what you configure.
+Prompt injection: Claude isolates web content, Codex cuts the network, OpenCode documents nothing specific.
+OpenCode's share command uploads whole sessions to a public link; disable it at work.
+Only Claude and Codex offer managed enterprise policy.</a:t>
             </a:r>
             <a:endParaRPr lang="en-US" dirty="0"/>
           </a:p>
@@ -1240,11 +1331,11 @@
           <a:p>
             <a:r>
               <a:rPr lang="en-US" dirty="0"/>
-              <a:t>My recommendations for Windows.
-Claude Desktop: start sessions in the WSL environment and enable the sandbox once. Untrusted repos go to a Cloud session. Never enable Bypass on the host.
-Codex: install the elevated Windows sandbox or run under WSL 2. Stay in Auto, and treat each "run outside the sandbox" approval as handing over full access.
-OpenCode: the app has no wall, so put it in one: Docker Sandboxes, a dev container or a VM. Then set bash and edit to ask and disable sharing.
-For all three: commit first, keep backups off the machine, and never point an agent at your home directory. Thank you.</a:t>
+              <a:t>None of this is theoretical. All three have public reports of deletions outside the repository.
+Claude Code: a cleanup command with a stray tilde removed a Mac home directory, and Windows reports include Git Bash deleting across the C drive. The policy saw the command; the shell expanded the path afterwards.
+Codex: the severe Windows case deleted ten workspace roots and Program Files folders, in Full access with approvals off. No verified sandbox escape.
+OpenCode: a June 2026 report describes an entire drive cleared. There was only a prompt.
+A prompt is not a boundary. The kernel or a VM is.</a:t>
             </a:r>
             <a:endParaRPr lang="en-US" dirty="0"/>
           </a:p>
@@ -1833,6 +1924,782 @@
 </p:sld>
 </file>
 
+<file path=ppt/slides/slide10.xml><?xml version="1.0" encoding="utf-8"?>
+<p:sld xmlns:a="http://schemas.openxmlformats.org/drawingml/2006/main" xmlns:r="http://schemas.openxmlformats.org/officeDocument/2006/relationships" xmlns:p="http://schemas.openxmlformats.org/presentationml/2006/main">
+  <p:cSld name="Slide 10">
+    <p:bg>
+      <p:bgPr>
+        <a:solidFill>
+          <a:srgbClr val="0B1220"/>
+        </a:solidFill>
+      </p:bgPr>
+    </p:bg>
+    <p:spTree>
+      <p:nvGrpSpPr>
+        <p:cNvPr id="1" name=""/>
+        <p:cNvGrpSpPr/>
+        <p:nvPr/>
+      </p:nvGrpSpPr>
+      <p:grpSpPr>
+        <a:xfrm>
+          <a:off x="0" y="0"/>
+          <a:ext cx="0" cy="0"/>
+          <a:chOff x="0" y="0"/>
+          <a:chExt cx="0" cy="0"/>
+        </a:xfrm>
+      </p:grpSpPr>
+      <p:sp>
+        <p:nvSpPr>
+          <p:cNvPr id="2" name="Text 0"/>
+          <p:cNvSpPr txBox="1"/>
+          <p:nvPr/>
+        </p:nvSpPr>
+        <p:spPr>
+          <a:xfrm>
+            <a:off x="457200" y="320040"/>
+            <a:ext cx="8229600" cy="548640"/>
+          </a:xfrm>
+          <a:prstGeom prst="rect">
+            <a:avLst/>
+          </a:prstGeom>
+          <a:noFill/>
+          <a:ln/>
+        </p:spPr>
+        <p:txBody>
+          <a:bodyPr wrap="square" lIns="0" tIns="0" rIns="0" bIns="0" rtlCol="0" anchor="ctr"/>
+          <a:lstStyle/>
+          <a:p>
+            <a:pPr indent="0" marL="0">
+              <a:buNone/>
+            </a:pPr>
+            <a:r>
+              <a:rPr lang="en-US" sz="2800" b="1" dirty="0">
+                <a:solidFill>
+                  <a:srgbClr val="EAF0FA"/>
+                </a:solidFill>
+                <a:latin typeface="Calibri" pitchFamily="34" charset="0"/>
+                <a:ea typeface="Calibri" pitchFamily="34" charset="-122"/>
+                <a:cs typeface="Calibri" pitchFamily="34" charset="-120"/>
+              </a:rPr>
+              <a:t>Recommendations for Windows users</a:t>
+            </a:r>
+            <a:endParaRPr lang="en-US" sz="2800" dirty="0"/>
+          </a:p>
+        </p:txBody>
+      </p:sp>
+      <p:sp>
+        <p:nvSpPr>
+          <p:cNvPr id="3" name="Text 1"/>
+          <p:cNvSpPr txBox="1"/>
+          <p:nvPr/>
+        </p:nvSpPr>
+        <p:spPr>
+          <a:xfrm>
+            <a:off x="457200" y="850392"/>
+            <a:ext cx="8229600" cy="320040"/>
+          </a:xfrm>
+          <a:prstGeom prst="rect">
+            <a:avLst/>
+          </a:prstGeom>
+          <a:noFill/>
+          <a:ln/>
+        </p:spPr>
+        <p:txBody>
+          <a:bodyPr wrap="square" lIns="0" tIns="0" rIns="0" bIns="0" rtlCol="0" anchor="ctr"/>
+          <a:lstStyle/>
+          <a:p>
+            <a:pPr indent="0" marL="0">
+              <a:buNone/>
+            </a:pPr>
+            <a:r>
+              <a:rPr lang="en-US" sz="1300" dirty="0">
+                <a:solidFill>
+                  <a:srgbClr val="9FB0C8"/>
+                </a:solidFill>
+                <a:latin typeface="Calibri" pitchFamily="34" charset="0"/>
+                <a:ea typeface="Calibri" pitchFamily="34" charset="-122"/>
+                <a:cs typeface="Calibri" pitchFamily="34" charset="-120"/>
+              </a:rPr>
+              <a:t>Get an enforced boundary, then tune the policy layer</a:t>
+            </a:r>
+            <a:endParaRPr lang="en-US" sz="1300" dirty="0"/>
+          </a:p>
+        </p:txBody>
+      </p:sp>
+      <p:sp>
+        <p:nvSpPr>
+          <p:cNvPr id="4" name="Shape 2"/>
+          <p:cNvSpPr/>
+          <p:nvPr/>
+        </p:nvSpPr>
+        <p:spPr>
+          <a:xfrm>
+            <a:off x="457200" y="1325880"/>
+            <a:ext cx="2697480" cy="2743200"/>
+          </a:xfrm>
+          <a:prstGeom prst="roundRect">
+            <a:avLst>
+              <a:gd name="adj" fmla="val 4068"/>
+            </a:avLst>
+          </a:prstGeom>
+          <a:solidFill>
+            <a:srgbClr val="141E33"/>
+          </a:solidFill>
+          <a:ln w="12700">
+            <a:solidFill>
+              <a:srgbClr val="2B3A57"/>
+            </a:solidFill>
+            <a:prstDash val="solid"/>
+          </a:ln>
+        </p:spPr>
+      </p:sp>
+      <p:sp>
+        <p:nvSpPr>
+          <p:cNvPr id="5" name="Shape 3"/>
+          <p:cNvSpPr/>
+          <p:nvPr/>
+        </p:nvSpPr>
+        <p:spPr>
+          <a:xfrm>
+            <a:off x="640080" y="1463040"/>
+            <a:ext cx="411480" cy="411480"/>
+          </a:xfrm>
+          <a:prstGeom prst="ellipse">
+            <a:avLst/>
+          </a:prstGeom>
+          <a:solidFill>
+            <a:srgbClr val="F5B341"/>
+          </a:solidFill>
+          <a:ln w="12700">
+            <a:solidFill>
+              <a:srgbClr val="F5B341"/>
+            </a:solidFill>
+            <a:prstDash val="solid"/>
+          </a:ln>
+        </p:spPr>
+      </p:sp>
+      <p:pic>
+        <p:nvPicPr>
+          <p:cNvPr id="6" name="Image 0" descr="preencoded.png">    </p:cNvPr>
+          <p:cNvPicPr>
+            <a:picLocks noChangeAspect="1"/>
+          </p:cNvPicPr>
+          <p:nvPr/>
+        </p:nvPicPr>
+        <p:blipFill>
+          <a:blip r:embed="rId1"/>
+          <a:stretch>
+            <a:fillRect/>
+          </a:stretch>
+        </p:blipFill>
+        <p:spPr>
+          <a:xfrm>
+            <a:off x="742950" y="1565910"/>
+            <a:ext cx="205740" cy="205740"/>
+          </a:xfrm>
+          <a:prstGeom prst="rect">
+            <a:avLst/>
+          </a:prstGeom>
+        </p:spPr>
+      </p:pic>
+      <p:sp>
+        <p:nvSpPr>
+          <p:cNvPr id="7" name="Text 4"/>
+          <p:cNvSpPr txBox="1"/>
+          <p:nvPr/>
+        </p:nvSpPr>
+        <p:spPr>
+          <a:xfrm>
+            <a:off x="1143000" y="1508760"/>
+            <a:ext cx="1920240" cy="320040"/>
+          </a:xfrm>
+          <a:prstGeom prst="rect">
+            <a:avLst/>
+          </a:prstGeom>
+          <a:noFill/>
+          <a:ln/>
+        </p:spPr>
+        <p:txBody>
+          <a:bodyPr wrap="square" lIns="0" tIns="0" rIns="0" bIns="0" rtlCol="0" anchor="ctr"/>
+          <a:lstStyle/>
+          <a:p>
+            <a:pPr indent="0" marL="0">
+              <a:buNone/>
+            </a:pPr>
+            <a:r>
+              <a:rPr lang="en-US" sz="1400" b="1" dirty="0">
+                <a:solidFill>
+                  <a:srgbClr val="EAF0FA"/>
+                </a:solidFill>
+                <a:latin typeface="Calibri" pitchFamily="34" charset="0"/>
+                <a:ea typeface="Calibri" pitchFamily="34" charset="-122"/>
+                <a:cs typeface="Calibri" pitchFamily="34" charset="-120"/>
+              </a:rPr>
+              <a:t>Claude Desktop</a:t>
+            </a:r>
+            <a:endParaRPr lang="en-US" sz="1400" dirty="0"/>
+          </a:p>
+        </p:txBody>
+      </p:sp>
+      <p:sp>
+        <p:nvSpPr>
+          <p:cNvPr id="8" name="Text 5"/>
+          <p:cNvSpPr txBox="1"/>
+          <p:nvPr/>
+        </p:nvSpPr>
+        <p:spPr>
+          <a:xfrm>
+            <a:off x="640080" y="2011680"/>
+            <a:ext cx="2377440" cy="1965960"/>
+          </a:xfrm>
+          <a:prstGeom prst="rect">
+            <a:avLst/>
+          </a:prstGeom>
+          <a:noFill/>
+          <a:ln/>
+        </p:spPr>
+        <p:txBody>
+          <a:bodyPr wrap="square" lIns="0" tIns="0" rIns="0" bIns="0" rtlCol="0" anchor="t"/>
+          <a:lstStyle/>
+          <a:p>
+            <a:pPr marL="152400" indent="-152400">
+              <a:spcAft>
+                <a:spcPts val="500"/>
+              </a:spcAft>
+              <a:buSzPct val="100000"/>
+              <a:buChar char="•"/>
+            </a:pPr>
+            <a:r>
+              <a:rPr lang="en-US" sz="1050" dirty="0">
+                <a:solidFill>
+                  <a:srgbClr val="EAF0FA"/>
+                </a:solidFill>
+                <a:latin typeface="Calibri" pitchFamily="34" charset="0"/>
+                <a:ea typeface="Calibri" pitchFamily="34" charset="-122"/>
+                <a:cs typeface="Calibri" pitchFamily="34" charset="-120"/>
+              </a:rPr>
+              <a:t>Start sessions in the WSL environment and run /sandbox once; keep denyRead on ~/.ssh and ~/.aws.</a:t>
+            </a:r>
+            <a:endParaRPr lang="en-US" sz="1050" dirty="0"/>
+          </a:p>
+          <a:p>
+            <a:pPr marL="152400" indent="-152400">
+              <a:spcAft>
+                <a:spcPts val="500"/>
+              </a:spcAft>
+              <a:buSzPct val="100000"/>
+              <a:buChar char="•"/>
+            </a:pPr>
+            <a:r>
+              <a:rPr lang="en-US" sz="1050" dirty="0">
+                <a:solidFill>
+                  <a:srgbClr val="EAF0FA"/>
+                </a:solidFill>
+                <a:latin typeface="Calibri" pitchFamily="34" charset="0"/>
+                <a:ea typeface="Calibri" pitchFamily="34" charset="-122"/>
+                <a:cs typeface="Calibri" pitchFamily="34" charset="-120"/>
+              </a:rPr>
+              <a:t>For untrusted repos use a Cloud session; never enable Bypass on the host.</a:t>
+            </a:r>
+            <a:endParaRPr lang="en-US" sz="1050" dirty="0"/>
+          </a:p>
+          <a:p>
+            <a:pPr marL="152400" indent="-152400">
+              <a:spcAft>
+                <a:spcPts val="500"/>
+              </a:spcAft>
+              <a:buSzPct val="100000"/>
+              <a:buChar char="•"/>
+            </a:pPr>
+            <a:r>
+              <a:rPr lang="en-US" sz="1050" dirty="0">
+                <a:solidFill>
+                  <a:srgbClr val="EAF0FA"/>
+                </a:solidFill>
+                <a:latin typeface="Calibri" pitchFamily="34" charset="0"/>
+                <a:ea typeface="Calibri" pitchFamily="34" charset="-122"/>
+                <a:cs typeface="Calibri" pitchFamily="34" charset="-120"/>
+              </a:rPr>
+              <a:t>Keep Auto or Manual; add deny rules for rm -rf and curl | bash in settings.</a:t>
+            </a:r>
+            <a:endParaRPr lang="en-US" sz="1050" dirty="0"/>
+          </a:p>
+        </p:txBody>
+      </p:sp>
+      <p:sp>
+        <p:nvSpPr>
+          <p:cNvPr id="9" name="Shape 6"/>
+          <p:cNvSpPr/>
+          <p:nvPr/>
+        </p:nvSpPr>
+        <p:spPr>
+          <a:xfrm>
+            <a:off x="3268980" y="1325880"/>
+            <a:ext cx="2697480" cy="2743200"/>
+          </a:xfrm>
+          <a:prstGeom prst="roundRect">
+            <a:avLst>
+              <a:gd name="adj" fmla="val 4068"/>
+            </a:avLst>
+          </a:prstGeom>
+          <a:solidFill>
+            <a:srgbClr val="141E33"/>
+          </a:solidFill>
+          <a:ln w="12700">
+            <a:solidFill>
+              <a:srgbClr val="2B3A57"/>
+            </a:solidFill>
+            <a:prstDash val="solid"/>
+          </a:ln>
+        </p:spPr>
+      </p:sp>
+      <p:sp>
+        <p:nvSpPr>
+          <p:cNvPr id="10" name="Shape 7"/>
+          <p:cNvSpPr/>
+          <p:nvPr/>
+        </p:nvSpPr>
+        <p:spPr>
+          <a:xfrm>
+            <a:off x="3451860" y="1463040"/>
+            <a:ext cx="411480" cy="411480"/>
+          </a:xfrm>
+          <a:prstGeom prst="ellipse">
+            <a:avLst/>
+          </a:prstGeom>
+          <a:solidFill>
+            <a:srgbClr val="5BA8FF"/>
+          </a:solidFill>
+          <a:ln w="12700">
+            <a:solidFill>
+              <a:srgbClr val="5BA8FF"/>
+            </a:solidFill>
+            <a:prstDash val="solid"/>
+          </a:ln>
+        </p:spPr>
+      </p:sp>
+      <p:pic>
+        <p:nvPicPr>
+          <p:cNvPr id="11" name="Image 1" descr="preencoded.png">    </p:cNvPr>
+          <p:cNvPicPr>
+            <a:picLocks noChangeAspect="1"/>
+          </p:cNvPicPr>
+          <p:nvPr/>
+        </p:nvPicPr>
+        <p:blipFill>
+          <a:blip r:embed="rId2"/>
+          <a:stretch>
+            <a:fillRect/>
+          </a:stretch>
+        </p:blipFill>
+        <p:spPr>
+          <a:xfrm>
+            <a:off x="3554730" y="1565910"/>
+            <a:ext cx="205740" cy="205740"/>
+          </a:xfrm>
+          <a:prstGeom prst="rect">
+            <a:avLst/>
+          </a:prstGeom>
+        </p:spPr>
+      </p:pic>
+      <p:sp>
+        <p:nvSpPr>
+          <p:cNvPr id="12" name="Text 8"/>
+          <p:cNvSpPr txBox="1"/>
+          <p:nvPr/>
+        </p:nvSpPr>
+        <p:spPr>
+          <a:xfrm>
+            <a:off x="3954780" y="1508760"/>
+            <a:ext cx="1920240" cy="320040"/>
+          </a:xfrm>
+          <a:prstGeom prst="rect">
+            <a:avLst/>
+          </a:prstGeom>
+          <a:noFill/>
+          <a:ln/>
+        </p:spPr>
+        <p:txBody>
+          <a:bodyPr wrap="square" lIns="0" tIns="0" rIns="0" bIns="0" rtlCol="0" anchor="ctr"/>
+          <a:lstStyle/>
+          <a:p>
+            <a:pPr indent="0" marL="0">
+              <a:buNone/>
+            </a:pPr>
+            <a:r>
+              <a:rPr lang="en-US" sz="1400" b="1" dirty="0">
+                <a:solidFill>
+                  <a:srgbClr val="EAF0FA"/>
+                </a:solidFill>
+                <a:latin typeface="Calibri" pitchFamily="34" charset="0"/>
+                <a:ea typeface="Calibri" pitchFamily="34" charset="-122"/>
+                <a:cs typeface="Calibri" pitchFamily="34" charset="-120"/>
+              </a:rPr>
+              <a:t>ChatGPT / Codex</a:t>
+            </a:r>
+            <a:endParaRPr lang="en-US" sz="1400" dirty="0"/>
+          </a:p>
+        </p:txBody>
+      </p:sp>
+      <p:sp>
+        <p:nvSpPr>
+          <p:cNvPr id="13" name="Text 9"/>
+          <p:cNvSpPr txBox="1"/>
+          <p:nvPr/>
+        </p:nvSpPr>
+        <p:spPr>
+          <a:xfrm>
+            <a:off x="3451860" y="2011680"/>
+            <a:ext cx="2377440" cy="1965960"/>
+          </a:xfrm>
+          <a:prstGeom prst="rect">
+            <a:avLst/>
+          </a:prstGeom>
+          <a:noFill/>
+          <a:ln/>
+        </p:spPr>
+        <p:txBody>
+          <a:bodyPr wrap="square" lIns="0" tIns="0" rIns="0" bIns="0" rtlCol="0" anchor="t"/>
+          <a:lstStyle/>
+          <a:p>
+            <a:pPr marL="152400" indent="-152400">
+              <a:spcAft>
+                <a:spcPts val="500"/>
+              </a:spcAft>
+              <a:buSzPct val="100000"/>
+              <a:buChar char="•"/>
+            </a:pPr>
+            <a:r>
+              <a:rPr lang="en-US" sz="1050" dirty="0">
+                <a:solidFill>
+                  <a:srgbClr val="EAF0FA"/>
+                </a:solidFill>
+                <a:latin typeface="Calibri" pitchFamily="34" charset="0"/>
+                <a:ea typeface="Calibri" pitchFamily="34" charset="-122"/>
+                <a:cs typeface="Calibri" pitchFamily="34" charset="-120"/>
+              </a:rPr>
+              <a:t>Install the elevated Windows sandbox (admin once) or run under WSL 2.</a:t>
+            </a:r>
+            <a:endParaRPr lang="en-US" sz="1050" dirty="0"/>
+          </a:p>
+          <a:p>
+            <a:pPr marL="152400" indent="-152400">
+              <a:spcAft>
+                <a:spcPts val="500"/>
+              </a:spcAft>
+              <a:buSzPct val="100000"/>
+              <a:buChar char="•"/>
+            </a:pPr>
+            <a:r>
+              <a:rPr lang="en-US" sz="1050" dirty="0">
+                <a:solidFill>
+                  <a:srgbClr val="EAF0FA"/>
+                </a:solidFill>
+                <a:latin typeface="Calibri" pitchFamily="34" charset="0"/>
+                <a:ea typeface="Calibri" pitchFamily="34" charset="-122"/>
+                <a:cs typeface="Calibri" pitchFamily="34" charset="-120"/>
+              </a:rPr>
+              <a:t>Stay in Auto (workspace-write, network off). Treat every "run outside sandbox" approval as a Full-access moment.</a:t>
+            </a:r>
+            <a:endParaRPr lang="en-US" sz="1050" dirty="0"/>
+          </a:p>
+          <a:p>
+            <a:pPr marL="152400" indent="-152400">
+              <a:spcAft>
+                <a:spcPts val="500"/>
+              </a:spcAft>
+              <a:buSzPct val="100000"/>
+              <a:buChar char="•"/>
+            </a:pPr>
+            <a:r>
+              <a:rPr lang="en-US" sz="1050" dirty="0">
+                <a:solidFill>
+                  <a:srgbClr val="EAF0FA"/>
+                </a:solidFill>
+                <a:latin typeface="Calibri" pitchFamily="34" charset="0"/>
+                <a:ea typeface="Calibri" pitchFamily="34" charset="-122"/>
+                <a:cs typeface="Calibri" pitchFamily="34" charset="-120"/>
+              </a:rPr>
+              <a:t>Never use Full access outside a disposable container.</a:t>
+            </a:r>
+            <a:endParaRPr lang="en-US" sz="1050" dirty="0"/>
+          </a:p>
+        </p:txBody>
+      </p:sp>
+      <p:sp>
+        <p:nvSpPr>
+          <p:cNvPr id="14" name="Shape 10"/>
+          <p:cNvSpPr/>
+          <p:nvPr/>
+        </p:nvSpPr>
+        <p:spPr>
+          <a:xfrm>
+            <a:off x="6080760" y="1325880"/>
+            <a:ext cx="2697480" cy="2743200"/>
+          </a:xfrm>
+          <a:prstGeom prst="roundRect">
+            <a:avLst>
+              <a:gd name="adj" fmla="val 4068"/>
+            </a:avLst>
+          </a:prstGeom>
+          <a:solidFill>
+            <a:srgbClr val="141E33"/>
+          </a:solidFill>
+          <a:ln w="12700">
+            <a:solidFill>
+              <a:srgbClr val="2B3A57"/>
+            </a:solidFill>
+            <a:prstDash val="solid"/>
+          </a:ln>
+        </p:spPr>
+      </p:sp>
+      <p:sp>
+        <p:nvSpPr>
+          <p:cNvPr id="15" name="Shape 11"/>
+          <p:cNvSpPr/>
+          <p:nvPr/>
+        </p:nvSpPr>
+        <p:spPr>
+          <a:xfrm>
+            <a:off x="6263640" y="1463040"/>
+            <a:ext cx="411480" cy="411480"/>
+          </a:xfrm>
+          <a:prstGeom prst="ellipse">
+            <a:avLst/>
+          </a:prstGeom>
+          <a:solidFill>
+            <a:srgbClr val="3DD68C"/>
+          </a:solidFill>
+          <a:ln w="12700">
+            <a:solidFill>
+              <a:srgbClr val="3DD68C"/>
+            </a:solidFill>
+            <a:prstDash val="solid"/>
+          </a:ln>
+        </p:spPr>
+      </p:sp>
+      <p:pic>
+        <p:nvPicPr>
+          <p:cNvPr id="16" name="Image 2" descr="preencoded.png">    </p:cNvPr>
+          <p:cNvPicPr>
+            <a:picLocks noChangeAspect="1"/>
+          </p:cNvPicPr>
+          <p:nvPr/>
+        </p:nvPicPr>
+        <p:blipFill>
+          <a:blip r:embed="rId3"/>
+          <a:stretch>
+            <a:fillRect/>
+          </a:stretch>
+        </p:blipFill>
+        <p:spPr>
+          <a:xfrm>
+            <a:off x="6366510" y="1565910"/>
+            <a:ext cx="205740" cy="205740"/>
+          </a:xfrm>
+          <a:prstGeom prst="rect">
+            <a:avLst/>
+          </a:prstGeom>
+        </p:spPr>
+      </p:pic>
+      <p:sp>
+        <p:nvSpPr>
+          <p:cNvPr id="17" name="Text 12"/>
+          <p:cNvSpPr txBox="1"/>
+          <p:nvPr/>
+        </p:nvSpPr>
+        <p:spPr>
+          <a:xfrm>
+            <a:off x="6766560" y="1508760"/>
+            <a:ext cx="1920240" cy="320040"/>
+          </a:xfrm>
+          <a:prstGeom prst="rect">
+            <a:avLst/>
+          </a:prstGeom>
+          <a:noFill/>
+          <a:ln/>
+        </p:spPr>
+        <p:txBody>
+          <a:bodyPr wrap="square" lIns="0" tIns="0" rIns="0" bIns="0" rtlCol="0" anchor="ctr"/>
+          <a:lstStyle/>
+          <a:p>
+            <a:pPr indent="0" marL="0">
+              <a:buNone/>
+            </a:pPr>
+            <a:r>
+              <a:rPr lang="en-US" sz="1400" b="1" dirty="0">
+                <a:solidFill>
+                  <a:srgbClr val="EAF0FA"/>
+                </a:solidFill>
+                <a:latin typeface="Calibri" pitchFamily="34" charset="0"/>
+                <a:ea typeface="Calibri" pitchFamily="34" charset="-122"/>
+                <a:cs typeface="Calibri" pitchFamily="34" charset="-120"/>
+              </a:rPr>
+              <a:t>OpenCode Desktop</a:t>
+            </a:r>
+            <a:endParaRPr lang="en-US" sz="1400" dirty="0"/>
+          </a:p>
+        </p:txBody>
+      </p:sp>
+      <p:sp>
+        <p:nvSpPr>
+          <p:cNvPr id="18" name="Text 13"/>
+          <p:cNvSpPr txBox="1"/>
+          <p:nvPr/>
+        </p:nvSpPr>
+        <p:spPr>
+          <a:xfrm>
+            <a:off x="6263640" y="2011680"/>
+            <a:ext cx="2377440" cy="1965960"/>
+          </a:xfrm>
+          <a:prstGeom prst="rect">
+            <a:avLst/>
+          </a:prstGeom>
+          <a:noFill/>
+          <a:ln/>
+        </p:spPr>
+        <p:txBody>
+          <a:bodyPr wrap="square" lIns="0" tIns="0" rIns="0" bIns="0" rtlCol="0" anchor="t"/>
+          <a:lstStyle/>
+          <a:p>
+            <a:pPr marL="152400" indent="-152400">
+              <a:spcAft>
+                <a:spcPts val="500"/>
+              </a:spcAft>
+              <a:buSzPct val="100000"/>
+              <a:buChar char="•"/>
+            </a:pPr>
+            <a:r>
+              <a:rPr lang="en-US" sz="1050" dirty="0">
+                <a:solidFill>
+                  <a:srgbClr val="EAF0FA"/>
+                </a:solidFill>
+                <a:latin typeface="Calibri" pitchFamily="34" charset="0"/>
+                <a:ea typeface="Calibri" pitchFamily="34" charset="-122"/>
+                <a:cs typeface="Calibri" pitchFamily="34" charset="-120"/>
+              </a:rPr>
+              <a:t>Run the server in Docker Sandboxes or a container and add it via "Add server"; WSL mode alone adds no sandbox.</a:t>
+            </a:r>
+            <a:endParaRPr lang="en-US" sz="1050" dirty="0"/>
+          </a:p>
+          <a:p>
+            <a:pPr marL="152400" indent="-152400">
+              <a:spcAft>
+                <a:spcPts val="500"/>
+              </a:spcAft>
+              <a:buSzPct val="100000"/>
+              <a:buChar char="•"/>
+            </a:pPr>
+            <a:r>
+              <a:rPr lang="en-US" sz="1050" dirty="0">
+                <a:solidFill>
+                  <a:srgbClr val="EAF0FA"/>
+                </a:solidFill>
+                <a:latin typeface="Calibri" pitchFamily="34" charset="0"/>
+                <a:ea typeface="Calibri" pitchFamily="34" charset="-122"/>
+                <a:cs typeface="Calibri" pitchFamily="34" charset="-120"/>
+              </a:rPr>
+              <a:t>Set bash and edit to "ask" for the build agent; deny rm *, format, and git push --force.</a:t>
+            </a:r>
+            <a:endParaRPr lang="en-US" sz="1050" dirty="0"/>
+          </a:p>
+          <a:p>
+            <a:pPr marL="152400" indent="-152400">
+              <a:spcAft>
+                <a:spcPts val="500"/>
+              </a:spcAft>
+              <a:buSzPct val="100000"/>
+              <a:buChar char="•"/>
+            </a:pPr>
+            <a:r>
+              <a:rPr lang="en-US" sz="1050" dirty="0">
+                <a:solidFill>
+                  <a:srgbClr val="EAF0FA"/>
+                </a:solidFill>
+                <a:latin typeface="Calibri" pitchFamily="34" charset="0"/>
+                <a:ea typeface="Calibri" pitchFamily="34" charset="-122"/>
+                <a:cs typeface="Calibri" pitchFamily="34" charset="-120"/>
+              </a:rPr>
+              <a:t>Set share to disabled; protect auth.json.</a:t>
+            </a:r>
+            <a:endParaRPr lang="en-US" sz="1050" dirty="0"/>
+          </a:p>
+        </p:txBody>
+      </p:sp>
+      <p:sp>
+        <p:nvSpPr>
+          <p:cNvPr id="19" name="Shape 14"/>
+          <p:cNvSpPr/>
+          <p:nvPr/>
+        </p:nvSpPr>
+        <p:spPr>
+          <a:xfrm>
+            <a:off x="457200" y="4206240"/>
+            <a:ext cx="8229600" cy="502920"/>
+          </a:xfrm>
+          <a:prstGeom prst="roundRect">
+            <a:avLst>
+              <a:gd name="adj" fmla="val 18182"/>
+            </a:avLst>
+          </a:prstGeom>
+          <a:solidFill>
+            <a:srgbClr val="F5B341"/>
+          </a:solidFill>
+          <a:ln w="12700">
+            <a:solidFill>
+              <a:srgbClr val="F5B341"/>
+            </a:solidFill>
+            <a:prstDash val="solid"/>
+          </a:ln>
+        </p:spPr>
+      </p:sp>
+      <p:sp>
+        <p:nvSpPr>
+          <p:cNvPr id="20" name="Text 15"/>
+          <p:cNvSpPr txBox="1"/>
+          <p:nvPr/>
+        </p:nvSpPr>
+        <p:spPr>
+          <a:xfrm>
+            <a:off x="640080" y="4206240"/>
+            <a:ext cx="7863840" cy="502920"/>
+          </a:xfrm>
+          <a:prstGeom prst="rect">
+            <a:avLst/>
+          </a:prstGeom>
+          <a:noFill/>
+          <a:ln/>
+        </p:spPr>
+        <p:txBody>
+          <a:bodyPr wrap="square" lIns="0" tIns="0" rIns="0" bIns="0" rtlCol="0" anchor="ctr"/>
+          <a:lstStyle/>
+          <a:p>
+            <a:pPr indent="0" marL="0">
+              <a:buNone/>
+            </a:pPr>
+            <a:r>
+              <a:rPr lang="en-US" sz="1300" b="1" dirty="0">
+                <a:solidFill>
+                  <a:srgbClr val="0B1220"/>
+                </a:solidFill>
+                <a:latin typeface="Calibri" pitchFamily="34" charset="0"/>
+                <a:ea typeface="Calibri" pitchFamily="34" charset="-122"/>
+                <a:cs typeface="Calibri" pitchFamily="34" charset="-120"/>
+              </a:rPr>
+              <a:t>For all three: commit before you start, keep backups outside the machine, and never run an agent in your home directory.</a:t>
+            </a:r>
+            <a:endParaRPr lang="en-US" sz="1300" dirty="0"/>
+          </a:p>
+        </p:txBody>
+      </p:sp>
+    </p:spTree>
+  </p:cSld>
+  <p:clrMapOvr>
+    <a:masterClrMapping/>
+  </p:clrMapOvr>
+</p:sld>
+</file>
+
 <file path=ppt/slides/slide2.xml><?xml version="1.0" encoding="utf-8"?>
 <p:sld xmlns:a="http://schemas.openxmlformats.org/drawingml/2006/main" xmlns:r="http://schemas.openxmlformats.org/officeDocument/2006/relationships" xmlns:p="http://schemas.openxmlformats.org/presentationml/2006/main">
   <p:cSld name="Slide 2">
@@ -3104,7 +3971,7 @@
                 <a:ea typeface="Calibri" pitchFamily="34" charset="-122"/>
                 <a:cs typeface="Calibri" pitchFamily="34" charset="-120"/>
               </a:rPr>
-              <a:t>Desktop can run the whole session inside a WSL 2 distro; bubblewrap sandbox limits writes to cwd and network to an allowlist.</a:t>
+              <a:t>Desktop runs the whole session inside a WSL 2 distro; with bubblewrap and socat installed, /sandbox limits writes to cwd and network to an allowlist.</a:t>
             </a:r>
             <a:endParaRPr lang="en-US" sz="1000" dirty="0"/>
           </a:p>
@@ -4878,7 +5745,7 @@
                 <a:ea typeface="Calibri" pitchFamily="34" charset="-122"/>
                 <a:cs typeface="Calibri" pitchFamily="34" charset="-120"/>
               </a:rPr>
-              <a:t>The upside, and the fix</a:t>
+              <a:t>The upside, and the way out</a:t>
             </a:r>
             <a:endParaRPr lang="en-US" sz="1300" dirty="0"/>
           </a:p>
@@ -4917,7 +5784,7 @@
                 <a:ea typeface="Calibri" pitchFamily="34" charset="-122"/>
                 <a:cs typeface="Calibri" pitchFamily="34" charset="-120"/>
               </a:rPr>
-              <a:t>MIT-licensed, auditable, works with local models so code never leaves the machine. The maintainers point to containers rather than kernel sandboxes: Docker Sandboxes has an official OpenCode profile, and community plugins wrap bash in Seatbelt or bubblewrap.</a:t>
+              <a:t>MIT-licensed, auditable, works with local models. The desktop can run its server inside WSL 2 or attach to any opencode serve over HTTP, so the runtime can live in a container. Docker Sandboxes has an official OpenCode profile.</a:t>
             </a:r>
             <a:endParaRPr lang="en-US" sz="1050" dirty="0"/>
           </a:p>
@@ -5027,6 +5894,639 @@
                 <a:ea typeface="Calibri" pitchFamily="34" charset="-122"/>
                 <a:cs typeface="Calibri" pitchFamily="34" charset="-120"/>
               </a:rPr>
+              <a:t>Running the agent inside WSL 2</a:t>
+            </a:r>
+            <a:endParaRPr lang="en-US" sz="2800" dirty="0"/>
+          </a:p>
+        </p:txBody>
+      </p:sp>
+      <p:sp>
+        <p:nvSpPr>
+          <p:cNvPr id="3" name="Text 1"/>
+          <p:cNvSpPr txBox="1"/>
+          <p:nvPr/>
+        </p:nvSpPr>
+        <p:spPr>
+          <a:xfrm>
+            <a:off x="457200" y="850392"/>
+            <a:ext cx="8229600" cy="320040"/>
+          </a:xfrm>
+          <a:prstGeom prst="rect">
+            <a:avLst/>
+          </a:prstGeom>
+          <a:noFill/>
+          <a:ln/>
+        </p:spPr>
+        <p:txBody>
+          <a:bodyPr wrap="square" lIns="0" tIns="0" rIns="0" bIns="0" rtlCol="0" anchor="ctr"/>
+          <a:lstStyle/>
+          <a:p>
+            <a:pPr indent="0" marL="0">
+              <a:buNone/>
+            </a:pPr>
+            <a:r>
+              <a:rPr lang="en-US" sz="1300" dirty="0">
+                <a:solidFill>
+                  <a:srgbClr val="9FB0C8"/>
+                </a:solidFill>
+                <a:latin typeface="Calibri" pitchFamily="34" charset="0"/>
+                <a:ea typeface="Calibri" pitchFamily="34" charset="-122"/>
+                <a:cs typeface="Calibri" pitchFamily="34" charset="-120"/>
+              </a:rPr>
+              <a:t>Both desktop apps can move the runtime into an Ubuntu distro; only one gets a sandbox there</a:t>
+            </a:r>
+            <a:endParaRPr lang="en-US" sz="1300" dirty="0"/>
+          </a:p>
+        </p:txBody>
+      </p:sp>
+      <p:sp>
+        <p:nvSpPr>
+          <p:cNvPr id="4" name="Shape 2"/>
+          <p:cNvSpPr/>
+          <p:nvPr/>
+        </p:nvSpPr>
+        <p:spPr>
+          <a:xfrm>
+            <a:off x="457200" y="1325880"/>
+            <a:ext cx="4023360" cy="3246120"/>
+          </a:xfrm>
+          <a:prstGeom prst="roundRect">
+            <a:avLst>
+              <a:gd name="adj" fmla="val 3380"/>
+            </a:avLst>
+          </a:prstGeom>
+          <a:solidFill>
+            <a:srgbClr val="141E33"/>
+          </a:solidFill>
+          <a:ln w="12700">
+            <a:solidFill>
+              <a:srgbClr val="2B3A57"/>
+            </a:solidFill>
+            <a:prstDash val="solid"/>
+          </a:ln>
+        </p:spPr>
+      </p:sp>
+      <p:sp>
+        <p:nvSpPr>
+          <p:cNvPr id="5" name="Shape 3"/>
+          <p:cNvSpPr/>
+          <p:nvPr/>
+        </p:nvSpPr>
+        <p:spPr>
+          <a:xfrm>
+            <a:off x="640080" y="1463040"/>
+            <a:ext cx="411480" cy="411480"/>
+          </a:xfrm>
+          <a:prstGeom prst="ellipse">
+            <a:avLst/>
+          </a:prstGeom>
+          <a:solidFill>
+            <a:srgbClr val="F5B341"/>
+          </a:solidFill>
+          <a:ln w="12700">
+            <a:solidFill>
+              <a:srgbClr val="F5B341"/>
+            </a:solidFill>
+            <a:prstDash val="solid"/>
+          </a:ln>
+        </p:spPr>
+      </p:sp>
+      <p:pic>
+        <p:nvPicPr>
+          <p:cNvPr id="6" name="Image 0" descr="preencoded.png">    </p:cNvPr>
+          <p:cNvPicPr>
+            <a:picLocks noChangeAspect="1"/>
+          </p:cNvPicPr>
+          <p:nvPr/>
+        </p:nvPicPr>
+        <p:blipFill>
+          <a:blip r:embed="rId1"/>
+          <a:stretch>
+            <a:fillRect/>
+          </a:stretch>
+        </p:blipFill>
+        <p:spPr>
+          <a:xfrm>
+            <a:off x="742950" y="1565910"/>
+            <a:ext cx="205740" cy="205740"/>
+          </a:xfrm>
+          <a:prstGeom prst="rect">
+            <a:avLst/>
+          </a:prstGeom>
+        </p:spPr>
+      </p:pic>
+      <p:sp>
+        <p:nvSpPr>
+          <p:cNvPr id="7" name="Text 4"/>
+          <p:cNvSpPr txBox="1"/>
+          <p:nvPr/>
+        </p:nvSpPr>
+        <p:spPr>
+          <a:xfrm>
+            <a:off x="1143000" y="1508760"/>
+            <a:ext cx="3108960" cy="320040"/>
+          </a:xfrm>
+          <a:prstGeom prst="rect">
+            <a:avLst/>
+          </a:prstGeom>
+          <a:noFill/>
+          <a:ln/>
+        </p:spPr>
+        <p:txBody>
+          <a:bodyPr wrap="square" lIns="0" tIns="0" rIns="0" bIns="0" rtlCol="0" anchor="ctr"/>
+          <a:lstStyle/>
+          <a:p>
+            <a:pPr indent="0" marL="0">
+              <a:buNone/>
+            </a:pPr>
+            <a:r>
+              <a:rPr lang="en-US" sz="1500" b="1" dirty="0">
+                <a:solidFill>
+                  <a:srgbClr val="EAF0FA"/>
+                </a:solidFill>
+                <a:latin typeface="Calibri" pitchFamily="34" charset="0"/>
+                <a:ea typeface="Calibri" pitchFamily="34" charset="-122"/>
+                <a:cs typeface="Calibri" pitchFamily="34" charset="-120"/>
+              </a:rPr>
+              <a:t>Claude Desktop</a:t>
+            </a:r>
+            <a:endParaRPr lang="en-US" sz="1500" dirty="0"/>
+          </a:p>
+        </p:txBody>
+      </p:sp>
+      <p:sp>
+        <p:nvSpPr>
+          <p:cNvPr id="8" name="Text 5"/>
+          <p:cNvSpPr txBox="1"/>
+          <p:nvPr/>
+        </p:nvSpPr>
+        <p:spPr>
+          <a:xfrm>
+            <a:off x="640080" y="1965960"/>
+            <a:ext cx="3657600" cy="2514600"/>
+          </a:xfrm>
+          <a:prstGeom prst="rect">
+            <a:avLst/>
+          </a:prstGeom>
+          <a:noFill/>
+          <a:ln/>
+        </p:spPr>
+        <p:txBody>
+          <a:bodyPr wrap="square" lIns="0" tIns="0" rIns="0" bIns="0" rtlCol="0" anchor="t"/>
+          <a:lstStyle/>
+          <a:p>
+            <a:pPr marL="152400" indent="-152400">
+              <a:spcAft>
+                <a:spcPts val="500"/>
+              </a:spcAft>
+              <a:buSzPct val="100000"/>
+              <a:buChar char="•"/>
+            </a:pPr>
+            <a:r>
+              <a:rPr lang="en-US" sz="1050" dirty="0">
+                <a:solidFill>
+                  <a:srgbClr val="EAF0FA"/>
+                </a:solidFill>
+                <a:latin typeface="Calibri" pitchFamily="34" charset="0"/>
+                <a:ea typeface="Calibri" pitchFamily="34" charset="-122"/>
+                <a:cs typeface="Calibri" pitchFamily="34" charset="-120"/>
+              </a:rPr>
+              <a:t>Pick a WSL 2 distro in the session picker; the whole session, tools and git run inside it with Linux paths.</a:t>
+            </a:r>
+            <a:endParaRPr lang="en-US" sz="1050" dirty="0"/>
+          </a:p>
+          <a:p>
+            <a:pPr marL="152400" indent="-152400">
+              <a:spcAft>
+                <a:spcPts val="500"/>
+              </a:spcAft>
+              <a:buSzPct val="100000"/>
+              <a:buChar char="•"/>
+            </a:pPr>
+            <a:r>
+              <a:rPr lang="en-US" sz="1050" dirty="0">
+                <a:solidFill>
+                  <a:srgbClr val="EAF0FA"/>
+                </a:solidFill>
+                <a:latin typeface="Calibri" pitchFamily="34" charset="0"/>
+                <a:ea typeface="Calibri" pitchFamily="34" charset="-122"/>
+                <a:cs typeface="Calibri" pitchFamily="34" charset="-120"/>
+              </a:rPr>
+              <a:t>Claude Code is installed in the distro on first use.</a:t>
+            </a:r>
+            <a:endParaRPr lang="en-US" sz="1050" dirty="0"/>
+          </a:p>
+          <a:p>
+            <a:pPr marL="152400" indent="-152400">
+              <a:spcAft>
+                <a:spcPts val="500"/>
+              </a:spcAft>
+              <a:buSzPct val="100000"/>
+              <a:buChar char="•"/>
+            </a:pPr>
+            <a:r>
+              <a:rPr lang="en-US" sz="1050" dirty="0">
+                <a:solidFill>
+                  <a:srgbClr val="EAF0FA"/>
+                </a:solidFill>
+                <a:latin typeface="Calibri" pitchFamily="34" charset="0"/>
+                <a:ea typeface="Calibri" pitchFamily="34" charset="-122"/>
+                <a:cs typeface="Calibri" pitchFamily="34" charset="-120"/>
+              </a:rPr>
+              <a:t>apt install bubblewrap socat, then /sandbox: writes limited to cwd and temp, network via allowlist proxy.</a:t>
+            </a:r>
+            <a:endParaRPr lang="en-US" sz="1050" dirty="0"/>
+          </a:p>
+          <a:p>
+            <a:pPr marL="152400" indent="-152400">
+              <a:spcAft>
+                <a:spcPts val="500"/>
+              </a:spcAft>
+              <a:buSzPct val="100000"/>
+              <a:buChar char="•"/>
+            </a:pPr>
+            <a:r>
+              <a:rPr lang="en-US" sz="1050" dirty="0">
+                <a:solidFill>
+                  <a:srgbClr val="EAF0FA"/>
+                </a:solidFill>
+                <a:latin typeface="Calibri" pitchFamily="34" charset="0"/>
+                <a:ea typeface="Calibri" pitchFamily="34" charset="-122"/>
+                <a:cs typeface="Calibri" pitchFamily="34" charset="-120"/>
+              </a:rPr>
+              <a:t>Optional seccomp filter blocks the Unix socket that lets WSL launch Windows binaries.</a:t>
+            </a:r>
+            <a:endParaRPr lang="en-US" sz="1050" dirty="0"/>
+          </a:p>
+          <a:p>
+            <a:pPr marL="152400" indent="-152400">
+              <a:spcAft>
+                <a:spcPts val="500"/>
+              </a:spcAft>
+              <a:buSzPct val="100000"/>
+              <a:buChar char="•"/>
+            </a:pPr>
+            <a:r>
+              <a:rPr lang="en-US" sz="1050" dirty="0">
+                <a:solidFill>
+                  <a:srgbClr val="EAF0FA"/>
+                </a:solidFill>
+                <a:latin typeface="Calibri" pitchFamily="34" charset="0"/>
+                <a:ea typeface="Calibri" pitchFamily="34" charset="-122"/>
+                <a:cs typeface="Calibri" pitchFamily="34" charset="-120"/>
+              </a:rPr>
+              <a:t>Native SSH sessions to a Linux or macOS host are also built in.</a:t>
+            </a:r>
+            <a:endParaRPr lang="en-US" sz="1050" dirty="0"/>
+          </a:p>
+        </p:txBody>
+      </p:sp>
+      <p:sp>
+        <p:nvSpPr>
+          <p:cNvPr id="9" name="Shape 6"/>
+          <p:cNvSpPr/>
+          <p:nvPr/>
+        </p:nvSpPr>
+        <p:spPr>
+          <a:xfrm>
+            <a:off x="4663440" y="1325880"/>
+            <a:ext cx="4023360" cy="3246120"/>
+          </a:xfrm>
+          <a:prstGeom prst="roundRect">
+            <a:avLst>
+              <a:gd name="adj" fmla="val 3380"/>
+            </a:avLst>
+          </a:prstGeom>
+          <a:solidFill>
+            <a:srgbClr val="141E33"/>
+          </a:solidFill>
+          <a:ln w="12700">
+            <a:solidFill>
+              <a:srgbClr val="2B3A57"/>
+            </a:solidFill>
+            <a:prstDash val="solid"/>
+          </a:ln>
+        </p:spPr>
+      </p:sp>
+      <p:sp>
+        <p:nvSpPr>
+          <p:cNvPr id="10" name="Shape 7"/>
+          <p:cNvSpPr/>
+          <p:nvPr/>
+        </p:nvSpPr>
+        <p:spPr>
+          <a:xfrm>
+            <a:off x="4846320" y="1463040"/>
+            <a:ext cx="411480" cy="411480"/>
+          </a:xfrm>
+          <a:prstGeom prst="ellipse">
+            <a:avLst/>
+          </a:prstGeom>
+          <a:solidFill>
+            <a:srgbClr val="FF6B6B"/>
+          </a:solidFill>
+          <a:ln w="12700">
+            <a:solidFill>
+              <a:srgbClr val="FF6B6B"/>
+            </a:solidFill>
+            <a:prstDash val="solid"/>
+          </a:ln>
+        </p:spPr>
+      </p:sp>
+      <p:pic>
+        <p:nvPicPr>
+          <p:cNvPr id="11" name="Image 1" descr="preencoded.png">    </p:cNvPr>
+          <p:cNvPicPr>
+            <a:picLocks noChangeAspect="1"/>
+          </p:cNvPicPr>
+          <p:nvPr/>
+        </p:nvPicPr>
+        <p:blipFill>
+          <a:blip r:embed="rId2"/>
+          <a:stretch>
+            <a:fillRect/>
+          </a:stretch>
+        </p:blipFill>
+        <p:spPr>
+          <a:xfrm>
+            <a:off x="4949190" y="1565910"/>
+            <a:ext cx="205740" cy="205740"/>
+          </a:xfrm>
+          <a:prstGeom prst="rect">
+            <a:avLst/>
+          </a:prstGeom>
+        </p:spPr>
+      </p:pic>
+      <p:sp>
+        <p:nvSpPr>
+          <p:cNvPr id="12" name="Text 8"/>
+          <p:cNvSpPr txBox="1"/>
+          <p:nvPr/>
+        </p:nvSpPr>
+        <p:spPr>
+          <a:xfrm>
+            <a:off x="5349240" y="1508760"/>
+            <a:ext cx="3108960" cy="320040"/>
+          </a:xfrm>
+          <a:prstGeom prst="rect">
+            <a:avLst/>
+          </a:prstGeom>
+          <a:noFill/>
+          <a:ln/>
+        </p:spPr>
+        <p:txBody>
+          <a:bodyPr wrap="square" lIns="0" tIns="0" rIns="0" bIns="0" rtlCol="0" anchor="ctr"/>
+          <a:lstStyle/>
+          <a:p>
+            <a:pPr indent="0" marL="0">
+              <a:buNone/>
+            </a:pPr>
+            <a:r>
+              <a:rPr lang="en-US" sz="1500" b="1" dirty="0">
+                <a:solidFill>
+                  <a:srgbClr val="EAF0FA"/>
+                </a:solidFill>
+                <a:latin typeface="Calibri" pitchFamily="34" charset="0"/>
+                <a:ea typeface="Calibri" pitchFamily="34" charset="-122"/>
+                <a:cs typeface="Calibri" pitchFamily="34" charset="-120"/>
+              </a:rPr>
+              <a:t>OpenCode Desktop</a:t>
+            </a:r>
+            <a:endParaRPr lang="en-US" sz="1500" dirty="0"/>
+          </a:p>
+        </p:txBody>
+      </p:sp>
+      <p:sp>
+        <p:nvSpPr>
+          <p:cNvPr id="13" name="Text 9"/>
+          <p:cNvSpPr txBox="1"/>
+          <p:nvPr/>
+        </p:nvSpPr>
+        <p:spPr>
+          <a:xfrm>
+            <a:off x="4846320" y="1965960"/>
+            <a:ext cx="3657600" cy="2514600"/>
+          </a:xfrm>
+          <a:prstGeom prst="rect">
+            <a:avLst/>
+          </a:prstGeom>
+          <a:noFill/>
+          <a:ln/>
+        </p:spPr>
+        <p:txBody>
+          <a:bodyPr wrap="square" lIns="0" tIns="0" rIns="0" bIns="0" rtlCol="0" anchor="t"/>
+          <a:lstStyle/>
+          <a:p>
+            <a:pPr marL="152400" indent="-152400">
+              <a:spcAft>
+                <a:spcPts val="500"/>
+              </a:spcAft>
+              <a:buSzPct val="100000"/>
+              <a:buChar char="•"/>
+            </a:pPr>
+            <a:r>
+              <a:rPr lang="en-US" sz="1050" dirty="0">
+                <a:solidFill>
+                  <a:srgbClr val="EAF0FA"/>
+                </a:solidFill>
+                <a:latin typeface="Calibri" pitchFamily="34" charset="0"/>
+                <a:ea typeface="Calibri" pitchFamily="34" charset="-122"/>
+                <a:cs typeface="Calibri" pitchFamily="34" charset="-120"/>
+              </a:rPr>
+              <a:t>Settings: WSL integration, Add WSL server; the app runs opencode serve inside the distro and talks to it over HTTP with basic auth.</a:t>
+            </a:r>
+            <a:endParaRPr lang="en-US" sz="1050" dirty="0"/>
+          </a:p>
+          <a:p>
+            <a:pPr marL="152400" indent="-152400">
+              <a:spcAft>
+                <a:spcPts val="500"/>
+              </a:spcAft>
+              <a:buSzPct val="100000"/>
+              <a:buChar char="•"/>
+            </a:pPr>
+            <a:r>
+              <a:rPr lang="en-US" sz="1050" dirty="0">
+                <a:solidFill>
+                  <a:srgbClr val="EAF0FA"/>
+                </a:solidFill>
+                <a:latin typeface="Calibri" pitchFamily="34" charset="0"/>
+                <a:ea typeface="Calibri" pitchFamily="34" charset="-122"/>
+                <a:cs typeface="Calibri" pitchFamily="34" charset="-120"/>
+              </a:rPr>
+              <a:t>The CLI is installed in the distro at the matching version. Shipped in v1.17.0 (June 2026).</a:t>
+            </a:r>
+            <a:endParaRPr lang="en-US" sz="1050" dirty="0"/>
+          </a:p>
+          <a:p>
+            <a:pPr marL="152400" indent="-152400">
+              <a:spcAft>
+                <a:spcPts val="500"/>
+              </a:spcAft>
+              <a:buSzPct val="100000"/>
+              <a:buChar char="•"/>
+            </a:pPr>
+            <a:r>
+              <a:rPr lang="en-US" sz="1050" dirty="0">
+                <a:solidFill>
+                  <a:srgbClr val="EAF0FA"/>
+                </a:solidFill>
+                <a:latin typeface="Calibri" pitchFamily="34" charset="0"/>
+                <a:ea typeface="Calibri" pitchFamily="34" charset="-122"/>
+                <a:cs typeface="Calibri" pitchFamily="34" charset="-120"/>
+              </a:rPr>
+              <a:t>Nothing sandboxes commands inside the distro: no bubblewrap or Landlock support exists in the code base.</a:t>
+            </a:r>
+            <a:endParaRPr lang="en-US" sz="1050" dirty="0"/>
+          </a:p>
+          <a:p>
+            <a:pPr marL="152400" indent="-152400">
+              <a:spcAft>
+                <a:spcPts val="500"/>
+              </a:spcAft>
+              <a:buSzPct val="100000"/>
+              <a:buChar char="•"/>
+            </a:pPr>
+            <a:r>
+              <a:rPr lang="en-US" sz="1050" dirty="0">
+                <a:solidFill>
+                  <a:srgbClr val="EAF0FA"/>
+                </a:solidFill>
+                <a:latin typeface="Calibri" pitchFamily="34" charset="0"/>
+                <a:ea typeface="Calibri" pitchFamily="34" charset="-122"/>
+                <a:cs typeface="Calibri" pitchFamily="34" charset="-120"/>
+              </a:rPr>
+              <a:t>Any opencode serve is reachable via Add server: a Docker Sandboxes microVM, a container, or an SSH port forward.</a:t>
+            </a:r>
+            <a:endParaRPr lang="en-US" sz="1050" dirty="0"/>
+          </a:p>
+          <a:p>
+            <a:pPr marL="152400" indent="-152400">
+              <a:spcAft>
+                <a:spcPts val="500"/>
+              </a:spcAft>
+              <a:buSzPct val="100000"/>
+              <a:buChar char="•"/>
+            </a:pPr>
+            <a:r>
+              <a:rPr lang="en-US" sz="1050" dirty="0">
+                <a:solidFill>
+                  <a:srgbClr val="EAF0FA"/>
+                </a:solidFill>
+                <a:latin typeface="Calibri" pitchFamily="34" charset="0"/>
+                <a:ea typeface="Calibri" pitchFamily="34" charset="-122"/>
+                <a:cs typeface="Calibri" pitchFamily="34" charset="-120"/>
+              </a:rPr>
+              <a:t>No native SSH sessions; remote workspaces are experimental.</a:t>
+            </a:r>
+            <a:endParaRPr lang="en-US" sz="1050" dirty="0"/>
+          </a:p>
+        </p:txBody>
+      </p:sp>
+      <p:sp>
+        <p:nvSpPr>
+          <p:cNvPr id="14" name="Text 10"/>
+          <p:cNvSpPr txBox="1"/>
+          <p:nvPr/>
+        </p:nvSpPr>
+        <p:spPr>
+          <a:xfrm>
+            <a:off x="457200" y="4754880"/>
+            <a:ext cx="8229600" cy="274320"/>
+          </a:xfrm>
+          <a:prstGeom prst="rect">
+            <a:avLst/>
+          </a:prstGeom>
+          <a:noFill/>
+          <a:ln/>
+        </p:spPr>
+        <p:txBody>
+          <a:bodyPr wrap="square" lIns="0" tIns="0" rIns="0" bIns="0" rtlCol="0" anchor="ctr"/>
+          <a:lstStyle/>
+          <a:p>
+            <a:pPr indent="0" marL="0">
+              <a:buNone/>
+            </a:pPr>
+            <a:r>
+              <a:rPr lang="en-US" sz="900" dirty="0">
+                <a:solidFill>
+                  <a:srgbClr val="9FB0C8"/>
+                </a:solidFill>
+                <a:latin typeface="Calibri" pitchFamily="34" charset="0"/>
+                <a:ea typeface="Calibri" pitchFamily="34" charset="-122"/>
+                <a:cs typeface="Calibri" pitchFamily="34" charset="-120"/>
+              </a:rPr>
+              <a:t>Sources: code.claude.com/docs (desktop-wsl, sandboxing); anomalyco/opencode packages/desktop/src/main/wsl, docs windows-wsl.mdx and server.mdx, PR #23407</a:t>
+            </a:r>
+            <a:endParaRPr lang="en-US" sz="900" dirty="0"/>
+          </a:p>
+        </p:txBody>
+      </p:sp>
+    </p:spTree>
+  </p:cSld>
+  <p:clrMapOvr>
+    <a:masterClrMapping/>
+  </p:clrMapOvr>
+</p:sld>
+</file>
+
+<file path=ppt/slides/slide7.xml><?xml version="1.0" encoding="utf-8"?>
+<p:sld xmlns:a="http://schemas.openxmlformats.org/drawingml/2006/main" xmlns:r="http://schemas.openxmlformats.org/officeDocument/2006/relationships" xmlns:p="http://schemas.openxmlformats.org/presentationml/2006/main">
+  <p:cSld name="Slide 7">
+    <p:bg>
+      <p:bgPr>
+        <a:solidFill>
+          <a:srgbClr val="0B1220"/>
+        </a:solidFill>
+      </p:bgPr>
+    </p:bg>
+    <p:spTree>
+      <p:nvGrpSpPr>
+        <p:cNvPr id="1" name=""/>
+        <p:cNvGrpSpPr/>
+        <p:nvPr/>
+      </p:nvGrpSpPr>
+      <p:grpSpPr>
+        <a:xfrm>
+          <a:off x="0" y="0"/>
+          <a:ext cx="0" cy="0"/>
+          <a:chOff x="0" y="0"/>
+          <a:chExt cx="0" cy="0"/>
+        </a:xfrm>
+      </p:grpSpPr>
+      <p:sp>
+        <p:nvSpPr>
+          <p:cNvPr id="2" name="Text 0"/>
+          <p:cNvSpPr txBox="1"/>
+          <p:nvPr/>
+        </p:nvSpPr>
+        <p:spPr>
+          <a:xfrm>
+            <a:off x="457200" y="320040"/>
+            <a:ext cx="8229600" cy="548640"/>
+          </a:xfrm>
+          <a:prstGeom prst="rect">
+            <a:avLst/>
+          </a:prstGeom>
+          <a:noFill/>
+          <a:ln/>
+        </p:spPr>
+        <p:txBody>
+          <a:bodyPr wrap="square" lIns="0" tIns="0" rIns="0" bIns="0" rtlCol="0" anchor="ctr"/>
+          <a:lstStyle/>
+          <a:p>
+            <a:pPr indent="0" marL="0">
+              <a:buNone/>
+            </a:pPr>
+            <a:r>
+              <a:rPr lang="en-US" sz="2800" b="1" dirty="0">
+                <a:solidFill>
+                  <a:srgbClr val="EAF0FA"/>
+                </a:solidFill>
+                <a:latin typeface="Calibri" pitchFamily="34" charset="0"/>
+                <a:ea typeface="Calibri" pitchFamily="34" charset="-122"/>
+                <a:cs typeface="Calibri" pitchFamily="34" charset="-120"/>
+              </a:rPr>
               <a:t>Sandboxing side by side</a:t>
             </a:r>
             <a:endParaRPr lang="en-US" sz="2800" dirty="0"/>
@@ -5074,7 +6574,7 @@
       </p:sp>
       <p:graphicFrame>
         <p:nvGraphicFramePr>
-          <p:cNvPr id="7" name="Table 0"/>
+          <p:cNvPr id="8" name="Table 0"/>
           <p:cNvGraphicFramePr>
             <a:graphicFrameLocks noGrp="1"/>
           </p:cNvGraphicFramePr>
@@ -5087,7 +6587,7 @@
           </p:nvPr>
         </p:nvGraphicFramePr>
         <p:xfrm>
-          <a:off x="457200" y="1280160"/>
+          <a:off x="457200" y="1234440"/>
           <a:ext cx="8229600" cy="914400"/>
         </p:xfrm>
         <a:graphic>
@@ -5095,12 +6595,12 @@
             <a:tbl>
               <a:tblPr/>
               <a:tblGrid>
-                <a:gridCol w="1554480"/>
-                <a:gridCol w="2286000"/>
+                <a:gridCol w="1463040"/>
+                <a:gridCol w="2377440"/>
                 <a:gridCol w="2194560"/>
                 <a:gridCol w="2194560"/>
               </a:tblGrid>
-              <a:tr h="384048">
+              <a:tr h="365760">
                 <a:tc>
                   <a:txBody>
                     <a:bodyPr/>
@@ -5116,7 +6616,7 @@
                       </a:endParaRPr>
                     </a:p>
                   </a:txBody>
-                  <a:tcPr marL="54864" marR="54864" marT="54864" marB="54864" anchor="ctr">
+                  <a:tcPr marL="45720" marR="45720" marT="45720" marB="45720" anchor="ctr">
                     <a:lnL w="9525" cap="flat" cmpd="sng" algn="ctr">
                       <a:solidFill>
                         <a:srgbClr val="2B3A57"/>
@@ -5184,7 +6684,7 @@
                       </a:endParaRPr>
                     </a:p>
                   </a:txBody>
-                  <a:tcPr marL="54864" marR="54864" marT="54864" marB="54864" anchor="ctr">
+                  <a:tcPr marL="45720" marR="45720" marT="45720" marB="45720" anchor="ctr">
                     <a:lnL w="9525" cap="flat" cmpd="sng" algn="ctr">
                       <a:solidFill>
                         <a:srgbClr val="2B3A57"/>
@@ -5252,7 +6752,7 @@
                       </a:endParaRPr>
                     </a:p>
                   </a:txBody>
-                  <a:tcPr marL="54864" marR="54864" marT="54864" marB="54864" anchor="ctr">
+                  <a:tcPr marL="45720" marR="45720" marT="45720" marB="45720" anchor="ctr">
                     <a:lnL w="9525" cap="flat" cmpd="sng" algn="ctr">
                       <a:solidFill>
                         <a:srgbClr val="2B3A57"/>
@@ -5320,7 +6820,7 @@
                       </a:endParaRPr>
                     </a:p>
                   </a:txBody>
-                  <a:tcPr marL="54864" marR="54864" marT="54864" marB="54864" anchor="ctr">
+                  <a:tcPr marL="45720" marR="45720" marT="45720" marB="45720" anchor="ctr">
                     <a:lnL w="9525" cap="flat" cmpd="sng" algn="ctr">
                       <a:solidFill>
                         <a:srgbClr val="2B3A57"/>
@@ -5363,7 +6863,7 @@
                   </a:tcPr>
                 </a:tc>
               </a:tr>
-              <a:tr h="384048">
+              <a:tr h="365760">
                 <a:tc>
                   <a:txBody>
                     <a:bodyPr/>
@@ -5390,7 +6890,7 @@
                       </a:endParaRPr>
                     </a:p>
                   </a:txBody>
-                  <a:tcPr marL="54864" marR="54864" marT="54864" marB="54864" anchor="ctr">
+                  <a:tcPr marL="45720" marR="45720" marT="45720" marB="45720" anchor="ctr">
                     <a:lnL w="9525" cap="flat" cmpd="sng" algn="ctr">
                       <a:solidFill>
                         <a:srgbClr val="2B3A57"/>
@@ -5458,7 +6958,7 @@
                       </a:endParaRPr>
                     </a:p>
                   </a:txBody>
-                  <a:tcPr marL="54864" marR="54864" marT="54864" marB="54864" anchor="ctr">
+                  <a:tcPr marL="45720" marR="45720" marT="45720" marB="45720" anchor="ctr">
                     <a:lnL w="9525" cap="flat" cmpd="sng" algn="ctr">
                       <a:solidFill>
                         <a:srgbClr val="2B3A57"/>
@@ -5526,7 +7026,7 @@
                       </a:endParaRPr>
                     </a:p>
                   </a:txBody>
-                  <a:tcPr marL="54864" marR="54864" marT="54864" marB="54864" anchor="ctr">
+                  <a:tcPr marL="45720" marR="45720" marT="45720" marB="45720" anchor="ctr">
                     <a:lnL w="9525" cap="flat" cmpd="sng" algn="ctr">
                       <a:solidFill>
                         <a:srgbClr val="2B3A57"/>
@@ -5594,7 +7094,7 @@
                       </a:endParaRPr>
                     </a:p>
                   </a:txBody>
-                  <a:tcPr marL="54864" marR="54864" marT="54864" marB="54864" anchor="ctr">
+                  <a:tcPr marL="45720" marR="45720" marT="45720" marB="45720" anchor="ctr">
                     <a:lnL w="9525" cap="flat" cmpd="sng" algn="ctr">
                       <a:solidFill>
                         <a:srgbClr val="2B3A57"/>
@@ -5637,7 +7137,7 @@
                   </a:tcPr>
                 </a:tc>
               </a:tr>
-              <a:tr h="384048">
+              <a:tr h="365760">
                 <a:tc>
                   <a:txBody>
                     <a:bodyPr/>
@@ -5664,7 +7164,7 @@
                       </a:endParaRPr>
                     </a:p>
                   </a:txBody>
-                  <a:tcPr marL="54864" marR="54864" marT="54864" marB="54864" anchor="ctr">
+                  <a:tcPr marL="45720" marR="45720" marT="45720" marB="45720" anchor="ctr">
                     <a:lnL w="9525" cap="flat" cmpd="sng" algn="ctr">
                       <a:solidFill>
                         <a:srgbClr val="2B3A57"/>
@@ -5732,7 +7232,7 @@
                       </a:endParaRPr>
                     </a:p>
                   </a:txBody>
-                  <a:tcPr marL="54864" marR="54864" marT="54864" marB="54864" anchor="ctr">
+                  <a:tcPr marL="45720" marR="45720" marT="45720" marB="45720" anchor="ctr">
                     <a:lnL w="9525" cap="flat" cmpd="sng" algn="ctr">
                       <a:solidFill>
                         <a:srgbClr val="2B3A57"/>
@@ -5800,7 +7300,7 @@
                       </a:endParaRPr>
                     </a:p>
                   </a:txBody>
-                  <a:tcPr marL="54864" marR="54864" marT="54864" marB="54864" anchor="ctr">
+                  <a:tcPr marL="45720" marR="45720" marT="45720" marB="45720" anchor="ctr">
                     <a:lnL w="9525" cap="flat" cmpd="sng" algn="ctr">
                       <a:solidFill>
                         <a:srgbClr val="2B3A57"/>
@@ -5868,7 +7368,7 @@
                       </a:endParaRPr>
                     </a:p>
                   </a:txBody>
-                  <a:tcPr marL="54864" marR="54864" marT="54864" marB="54864" anchor="ctr">
+                  <a:tcPr marL="45720" marR="45720" marT="45720" marB="45720" anchor="ctr">
                     <a:lnL w="9525" cap="flat" cmpd="sng" algn="ctr">
                       <a:solidFill>
                         <a:srgbClr val="2B3A57"/>
@@ -5911,7 +7411,7 @@
                   </a:tcPr>
                 </a:tc>
               </a:tr>
-              <a:tr h="384048">
+              <a:tr h="365760">
                 <a:tc>
                   <a:txBody>
                     <a:bodyPr/>
@@ -5938,7 +7438,7 @@
                       </a:endParaRPr>
                     </a:p>
                   </a:txBody>
-                  <a:tcPr marL="54864" marR="54864" marT="54864" marB="54864" anchor="ctr">
+                  <a:tcPr marL="45720" marR="45720" marT="45720" marB="45720" anchor="ctr">
                     <a:lnL w="9525" cap="flat" cmpd="sng" algn="ctr">
                       <a:solidFill>
                         <a:srgbClr val="2B3A57"/>
@@ -6006,7 +7506,7 @@
                       </a:endParaRPr>
                     </a:p>
                   </a:txBody>
-                  <a:tcPr marL="54864" marR="54864" marT="54864" marB="54864" anchor="ctr">
+                  <a:tcPr marL="45720" marR="45720" marT="45720" marB="45720" anchor="ctr">
                     <a:lnL w="9525" cap="flat" cmpd="sng" algn="ctr">
                       <a:solidFill>
                         <a:srgbClr val="2B3A57"/>
@@ -6074,7 +7574,7 @@
                       </a:endParaRPr>
                     </a:p>
                   </a:txBody>
-                  <a:tcPr marL="54864" marR="54864" marT="54864" marB="54864" anchor="ctr">
+                  <a:tcPr marL="45720" marR="45720" marT="45720" marB="45720" anchor="ctr">
                     <a:lnL w="9525" cap="flat" cmpd="sng" algn="ctr">
                       <a:solidFill>
                         <a:srgbClr val="2B3A57"/>
@@ -6142,7 +7642,7 @@
                       </a:endParaRPr>
                     </a:p>
                   </a:txBody>
-                  <a:tcPr marL="54864" marR="54864" marT="54864" marB="54864" anchor="ctr">
+                  <a:tcPr marL="45720" marR="45720" marT="45720" marB="45720" anchor="ctr">
                     <a:lnL w="9525" cap="flat" cmpd="sng" algn="ctr">
                       <a:solidFill>
                         <a:srgbClr val="2B3A57"/>
@@ -6185,7 +7685,7 @@
                   </a:tcPr>
                 </a:tc>
               </a:tr>
-              <a:tr h="384048">
+              <a:tr h="365760">
                 <a:tc>
                   <a:txBody>
                     <a:bodyPr/>
@@ -6212,7 +7712,7 @@
                       </a:endParaRPr>
                     </a:p>
                   </a:txBody>
-                  <a:tcPr marL="54864" marR="54864" marT="54864" marB="54864" anchor="ctr">
+                  <a:tcPr marL="45720" marR="45720" marT="45720" marB="45720" anchor="ctr">
                     <a:lnL w="9525" cap="flat" cmpd="sng" algn="ctr">
                       <a:solidFill>
                         <a:srgbClr val="2B3A57"/>
@@ -6280,7 +7780,7 @@
                       </a:endParaRPr>
                     </a:p>
                   </a:txBody>
-                  <a:tcPr marL="54864" marR="54864" marT="54864" marB="54864" anchor="ctr">
+                  <a:tcPr marL="45720" marR="45720" marT="45720" marB="45720" anchor="ctr">
                     <a:lnL w="9525" cap="flat" cmpd="sng" algn="ctr">
                       <a:solidFill>
                         <a:srgbClr val="2B3A57"/>
@@ -6348,7 +7848,7 @@
                       </a:endParaRPr>
                     </a:p>
                   </a:txBody>
-                  <a:tcPr marL="54864" marR="54864" marT="54864" marB="54864" anchor="ctr">
+                  <a:tcPr marL="45720" marR="45720" marT="45720" marB="45720" anchor="ctr">
                     <a:lnL w="9525" cap="flat" cmpd="sng" algn="ctr">
                       <a:solidFill>
                         <a:srgbClr val="2B3A57"/>
@@ -6416,7 +7916,7 @@
                       </a:endParaRPr>
                     </a:p>
                   </a:txBody>
-                  <a:tcPr marL="54864" marR="54864" marT="54864" marB="54864" anchor="ctr">
+                  <a:tcPr marL="45720" marR="45720" marT="45720" marB="45720" anchor="ctr">
                     <a:lnL w="9525" cap="flat" cmpd="sng" algn="ctr">
                       <a:solidFill>
                         <a:srgbClr val="2B3A57"/>
@@ -6459,7 +7959,7 @@
                   </a:tcPr>
                 </a:tc>
               </a:tr>
-              <a:tr h="384048">
+              <a:tr h="365760">
                 <a:tc>
                   <a:txBody>
                     <a:bodyPr/>
@@ -6486,7 +7986,7 @@
                       </a:endParaRPr>
                     </a:p>
                   </a:txBody>
-                  <a:tcPr marL="54864" marR="54864" marT="54864" marB="54864" anchor="ctr">
+                  <a:tcPr marL="45720" marR="45720" marT="45720" marB="45720" anchor="ctr">
                     <a:lnL w="9525" cap="flat" cmpd="sng" algn="ctr">
                       <a:solidFill>
                         <a:srgbClr val="2B3A57"/>
@@ -6545,7 +8045,7 @@
                           <a:ea typeface="Calibri" pitchFamily="34" charset="-122"/>
                           <a:cs typeface="Calibri" pitchFamily="34" charset="-120"/>
                         </a:rPr>
-                        <a:t>Sandbox: allowlist proxy, no domains pre-allowed. Unsandboxed: curl/wget prompt</a:t>
+                        <a:t>Sandbox: allowlist proxy, no domains pre-allowed; unsandboxed: curl/wget prompt</a:t>
                       </a:r>
                       <a:endParaRPr lang="en-US" sz="1000" dirty="0">
                         <a:latin typeface="Calibri" charset="0"/>
@@ -6554,7 +8054,7 @@
                       </a:endParaRPr>
                     </a:p>
                   </a:txBody>
-                  <a:tcPr marL="54864" marR="54864" marT="54864" marB="54864" anchor="ctr">
+                  <a:tcPr marL="45720" marR="45720" marT="45720" marB="45720" anchor="ctr">
                     <a:lnL w="9525" cap="flat" cmpd="sng" algn="ctr">
                       <a:solidFill>
                         <a:srgbClr val="2B3A57"/>
@@ -6622,7 +8122,7 @@
                       </a:endParaRPr>
                     </a:p>
                   </a:txBody>
-                  <a:tcPr marL="54864" marR="54864" marT="54864" marB="54864" anchor="ctr">
+                  <a:tcPr marL="45720" marR="45720" marT="45720" marB="45720" anchor="ctr">
                     <a:lnL w="9525" cap="flat" cmpd="sng" algn="ctr">
                       <a:solidFill>
                         <a:srgbClr val="2B3A57"/>
@@ -6690,7 +8190,7 @@
                       </a:endParaRPr>
                     </a:p>
                   </a:txBody>
-                  <a:tcPr marL="54864" marR="54864" marT="54864" marB="54864" anchor="ctr">
+                  <a:tcPr marL="45720" marR="45720" marT="45720" marB="45720" anchor="ctr">
                     <a:lnL w="9525" cap="flat" cmpd="sng" algn="ctr">
                       <a:solidFill>
                         <a:srgbClr val="2B3A57"/>
@@ -6733,7 +8233,7 @@
                   </a:tcPr>
                 </a:tc>
               </a:tr>
-              <a:tr h="384048">
+              <a:tr h="365760">
                 <a:tc>
                   <a:txBody>
                     <a:bodyPr/>
@@ -6760,7 +8260,7 @@
                       </a:endParaRPr>
                     </a:p>
                   </a:txBody>
-                  <a:tcPr marL="54864" marR="54864" marT="54864" marB="54864" anchor="ctr">
+                  <a:tcPr marL="45720" marR="45720" marT="45720" marB="45720" anchor="ctr">
                     <a:lnL w="9525" cap="flat" cmpd="sng" algn="ctr">
                       <a:solidFill>
                         <a:srgbClr val="2B3A57"/>
@@ -6819,7 +8319,7 @@
                           <a:ea typeface="Calibri" pitchFamily="34" charset="-122"/>
                           <a:cs typeface="Calibri" pitchFamily="34" charset="-120"/>
                         </a:rPr>
-                        <a:t>Bypass permissions mode; unsandboxed retry (can be disabled by policy)</a:t>
+                        <a:t>Bypass mode; unsandboxed retry (policy can disable)</a:t>
                       </a:r>
                       <a:endParaRPr lang="en-US" sz="1000" dirty="0">
                         <a:latin typeface="Calibri" charset="0"/>
@@ -6828,7 +8328,7 @@
                       </a:endParaRPr>
                     </a:p>
                   </a:txBody>
-                  <a:tcPr marL="54864" marR="54864" marT="54864" marB="54864" anchor="ctr">
+                  <a:tcPr marL="45720" marR="45720" marT="45720" marB="45720" anchor="ctr">
                     <a:lnL w="9525" cap="flat" cmpd="sng" algn="ctr">
                       <a:solidFill>
                         <a:srgbClr val="2B3A57"/>
@@ -6896,7 +8396,7 @@
                       </a:endParaRPr>
                     </a:p>
                   </a:txBody>
-                  <a:tcPr marL="54864" marR="54864" marT="54864" marB="54864" anchor="ctr">
+                  <a:tcPr marL="45720" marR="45720" marT="45720" marB="45720" anchor="ctr">
                     <a:lnL w="9525" cap="flat" cmpd="sng" algn="ctr">
                       <a:solidFill>
                         <a:srgbClr val="2B3A57"/>
@@ -6964,7 +8464,7 @@
                       </a:endParaRPr>
                     </a:p>
                   </a:txBody>
-                  <a:tcPr marL="54864" marR="54864" marT="54864" marB="54864" anchor="ctr">
+                  <a:tcPr marL="45720" marR="45720" marT="45720" marB="45720" anchor="ctr">
                     <a:lnL w="9525" cap="flat" cmpd="sng" algn="ctr">
                       <a:solidFill>
                         <a:srgbClr val="2B3A57"/>
@@ -7007,7 +8507,7 @@
                   </a:tcPr>
                 </a:tc>
               </a:tr>
-              <a:tr h="384048">
+              <a:tr h="365760">
                 <a:tc>
                   <a:txBody>
                     <a:bodyPr/>
@@ -7034,7 +8534,7 @@
                       </a:endParaRPr>
                     </a:p>
                   </a:txBody>
-                  <a:tcPr marL="54864" marR="54864" marT="54864" marB="54864" anchor="ctr">
+                  <a:tcPr marL="45720" marR="45720" marT="45720" marB="45720" anchor="ctr">
                     <a:lnL w="9525" cap="flat" cmpd="sng" algn="ctr">
                       <a:solidFill>
                         <a:srgbClr val="2B3A57"/>
@@ -7102,7 +8602,7 @@
                       </a:endParaRPr>
                     </a:p>
                   </a:txBody>
-                  <a:tcPr marL="54864" marR="54864" marT="54864" marB="54864" anchor="ctr">
+                  <a:tcPr marL="45720" marR="45720" marT="45720" marB="45720" anchor="ctr">
                     <a:lnL w="9525" cap="flat" cmpd="sng" algn="ctr">
                       <a:solidFill>
                         <a:srgbClr val="2B3A57"/>
@@ -7170,7 +8670,7 @@
                       </a:endParaRPr>
                     </a:p>
                   </a:txBody>
-                  <a:tcPr marL="54864" marR="54864" marT="54864" marB="54864" anchor="ctr">
+                  <a:tcPr marL="45720" marR="45720" marT="45720" marB="45720" anchor="ctr">
                     <a:lnL w="9525" cap="flat" cmpd="sng" algn="ctr">
                       <a:solidFill>
                         <a:srgbClr val="2B3A57"/>
@@ -7229,7 +8729,7 @@
                           <a:ea typeface="Calibri" pitchFamily="34" charset="-122"/>
                           <a:cs typeface="Calibri" pitchFamily="34" charset="-120"/>
                         </a:rPr>
-                        <a:t>None built in; Docker Sandboxes profile, remote workspaces</a:t>
+                        <a:t>WSL 2 server mode, no sandbox inside; GUI can attach to a server in Docker Sandboxes</a:t>
                       </a:r>
                       <a:endParaRPr lang="en-US" sz="1000" dirty="0">
                         <a:latin typeface="Calibri" charset="0"/>
@@ -7238,7 +8738,7 @@
                       </a:endParaRPr>
                     </a:p>
                   </a:txBody>
-                  <a:tcPr marL="54864" marR="54864" marT="54864" marB="54864" anchor="ctr">
+                  <a:tcPr marL="45720" marR="45720" marT="45720" marB="45720" anchor="ctr">
                     <a:lnL w="9525" cap="flat" cmpd="sng" algn="ctr">
                       <a:solidFill>
                         <a:srgbClr val="2B3A57"/>
@@ -7293,9 +8793,9 @@
 </p:sld>
 </file>
 
-<file path=ppt/slides/slide7.xml><?xml version="1.0" encoding="utf-8"?>
+<file path=ppt/slides/slide8.xml><?xml version="1.0" encoding="utf-8"?>
 <p:sld xmlns:a="http://schemas.openxmlformats.org/drawingml/2006/main" xmlns:r="http://schemas.openxmlformats.org/officeDocument/2006/relationships" xmlns:p="http://schemas.openxmlformats.org/presentationml/2006/main">
-  <p:cSld name="Slide 7">
+  <p:cSld name="Slide 8">
     <p:bg>
       <p:bgPr>
         <a:solidFill>
@@ -7397,7 +8897,7 @@
       </p:sp>
       <p:graphicFrame>
         <p:nvGraphicFramePr>
-          <p:cNvPr id="8" name="Table 0"/>
+          <p:cNvPr id="9" name="Table 0"/>
           <p:cNvGraphicFramePr>
             <a:graphicFrameLocks noGrp="1"/>
           </p:cNvGraphicFramePr>
@@ -9342,851 +10842,6 @@
 </p:sld>
 </file>
 
-<file path=ppt/slides/slide8.xml><?xml version="1.0" encoding="utf-8"?>
-<p:sld xmlns:a="http://schemas.openxmlformats.org/drawingml/2006/main" xmlns:r="http://schemas.openxmlformats.org/officeDocument/2006/relationships" xmlns:p="http://schemas.openxmlformats.org/presentationml/2006/main">
-  <p:cSld name="Slide 8">
-    <p:bg>
-      <p:bgPr>
-        <a:solidFill>
-          <a:srgbClr val="0B1220"/>
-        </a:solidFill>
-      </p:bgPr>
-    </p:bg>
-    <p:spTree>
-      <p:nvGrpSpPr>
-        <p:cNvPr id="1" name=""/>
-        <p:cNvGrpSpPr/>
-        <p:nvPr/>
-      </p:nvGrpSpPr>
-      <p:grpSpPr>
-        <a:xfrm>
-          <a:off x="0" y="0"/>
-          <a:ext cx="0" cy="0"/>
-          <a:chOff x="0" y="0"/>
-          <a:chExt cx="0" cy="0"/>
-        </a:xfrm>
-      </p:grpSpPr>
-      <p:sp>
-        <p:nvSpPr>
-          <p:cNvPr id="2" name="Text 0"/>
-          <p:cNvSpPr txBox="1"/>
-          <p:nvPr/>
-        </p:nvSpPr>
-        <p:spPr>
-          <a:xfrm>
-            <a:off x="457200" y="320040"/>
-            <a:ext cx="8229600" cy="548640"/>
-          </a:xfrm>
-          <a:prstGeom prst="rect">
-            <a:avLst/>
-          </a:prstGeom>
-          <a:noFill/>
-          <a:ln/>
-        </p:spPr>
-        <p:txBody>
-          <a:bodyPr wrap="square" lIns="0" tIns="0" rIns="0" bIns="0" rtlCol="0" anchor="ctr"/>
-          <a:lstStyle/>
-          <a:p>
-            <a:pPr indent="0" marL="0">
-              <a:buNone/>
-            </a:pPr>
-            <a:r>
-              <a:rPr lang="en-US" sz="2800" b="1" dirty="0">
-                <a:solidFill>
-                  <a:srgbClr val="EAF0FA"/>
-                </a:solidFill>
-                <a:latin typeface="Calibri" pitchFamily="34" charset="0"/>
-                <a:ea typeface="Calibri" pitchFamily="34" charset="-122"/>
-                <a:cs typeface="Calibri" pitchFamily="34" charset="-120"/>
-              </a:rPr>
-              <a:t>It has happened with all three</a:t>
-            </a:r>
-            <a:endParaRPr lang="en-US" sz="2800" dirty="0"/>
-          </a:p>
-        </p:txBody>
-      </p:sp>
-      <p:sp>
-        <p:nvSpPr>
-          <p:cNvPr id="3" name="Text 1"/>
-          <p:cNvSpPr txBox="1"/>
-          <p:nvPr/>
-        </p:nvSpPr>
-        <p:spPr>
-          <a:xfrm>
-            <a:off x="457200" y="850392"/>
-            <a:ext cx="8229600" cy="320040"/>
-          </a:xfrm>
-          <a:prstGeom prst="rect">
-            <a:avLst/>
-          </a:prstGeom>
-          <a:noFill/>
-          <a:ln/>
-        </p:spPr>
-        <p:txBody>
-          <a:bodyPr wrap="square" lIns="0" tIns="0" rIns="0" bIns="0" rtlCol="0" anchor="ctr"/>
-          <a:lstStyle/>
-          <a:p>
-            <a:pPr indent="0" marL="0">
-              <a:buNone/>
-            </a:pPr>
-            <a:r>
-              <a:rPr lang="en-US" sz="1300" dirty="0">
-                <a:solidFill>
-                  <a:srgbClr val="9FB0C8"/>
-                </a:solidFill>
-                <a:latin typeface="Calibri" pitchFamily="34" charset="0"/>
-                <a:ea typeface="Calibri" pitchFamily="34" charset="-122"/>
-                <a:cs typeface="Calibri" pitchFamily="34" charset="-120"/>
-              </a:rPr>
-              <a:t>Public reports of deletions outside the repository, 2025 to 2026</a:t>
-            </a:r>
-            <a:endParaRPr lang="en-US" sz="1300" dirty="0"/>
-          </a:p>
-        </p:txBody>
-      </p:sp>
-      <p:sp>
-        <p:nvSpPr>
-          <p:cNvPr id="4" name="Shape 2"/>
-          <p:cNvSpPr/>
-          <p:nvPr/>
-        </p:nvSpPr>
-        <p:spPr>
-          <a:xfrm>
-            <a:off x="457200" y="1325880"/>
-            <a:ext cx="2697480" cy="3291840"/>
-          </a:xfrm>
-          <a:prstGeom prst="roundRect">
-            <a:avLst>
-              <a:gd name="adj" fmla="val 4068"/>
-            </a:avLst>
-          </a:prstGeom>
-          <a:solidFill>
-            <a:srgbClr val="141E33"/>
-          </a:solidFill>
-          <a:ln w="12700">
-            <a:solidFill>
-              <a:srgbClr val="2B3A57"/>
-            </a:solidFill>
-            <a:prstDash val="solid"/>
-          </a:ln>
-        </p:spPr>
-      </p:sp>
-      <p:sp>
-        <p:nvSpPr>
-          <p:cNvPr id="5" name="Shape 3"/>
-          <p:cNvSpPr/>
-          <p:nvPr/>
-        </p:nvSpPr>
-        <p:spPr>
-          <a:xfrm>
-            <a:off x="640080" y="1463040"/>
-            <a:ext cx="384048" cy="384048"/>
-          </a:xfrm>
-          <a:prstGeom prst="ellipse">
-            <a:avLst/>
-          </a:prstGeom>
-          <a:solidFill>
-            <a:srgbClr val="F5B341"/>
-          </a:solidFill>
-          <a:ln w="12700">
-            <a:solidFill>
-              <a:srgbClr val="F5B341"/>
-            </a:solidFill>
-            <a:prstDash val="solid"/>
-          </a:ln>
-        </p:spPr>
-      </p:sp>
-      <p:pic>
-        <p:nvPicPr>
-          <p:cNvPr id="6" name="Image 0" descr="preencoded.png">    </p:cNvPr>
-          <p:cNvPicPr>
-            <a:picLocks noChangeAspect="1"/>
-          </p:cNvPicPr>
-          <p:nvPr/>
-        </p:nvPicPr>
-        <p:blipFill>
-          <a:blip r:embed="rId1"/>
-          <a:stretch>
-            <a:fillRect/>
-          </a:stretch>
-        </p:blipFill>
-        <p:spPr>
-          <a:xfrm>
-            <a:off x="736092" y="1559052"/>
-            <a:ext cx="192024" cy="192024"/>
-          </a:xfrm>
-          <a:prstGeom prst="rect">
-            <a:avLst/>
-          </a:prstGeom>
-        </p:spPr>
-      </p:pic>
-      <p:sp>
-        <p:nvSpPr>
-          <p:cNvPr id="7" name="Text 4"/>
-          <p:cNvSpPr txBox="1"/>
-          <p:nvPr/>
-        </p:nvSpPr>
-        <p:spPr>
-          <a:xfrm>
-            <a:off x="1115568" y="1490472"/>
-            <a:ext cx="1920240" cy="320040"/>
-          </a:xfrm>
-          <a:prstGeom prst="rect">
-            <a:avLst/>
-          </a:prstGeom>
-          <a:noFill/>
-          <a:ln/>
-        </p:spPr>
-        <p:txBody>
-          <a:bodyPr wrap="square" lIns="0" tIns="0" rIns="0" bIns="0" rtlCol="0" anchor="ctr"/>
-          <a:lstStyle/>
-          <a:p>
-            <a:pPr indent="0" marL="0">
-              <a:buNone/>
-            </a:pPr>
-            <a:r>
-              <a:rPr lang="en-US" sz="1400" b="1" dirty="0">
-                <a:solidFill>
-                  <a:srgbClr val="EAF0FA"/>
-                </a:solidFill>
-                <a:latin typeface="Calibri" pitchFamily="34" charset="0"/>
-                <a:ea typeface="Calibri" pitchFamily="34" charset="-122"/>
-                <a:cs typeface="Calibri" pitchFamily="34" charset="-120"/>
-              </a:rPr>
-              <a:t>Claude Code</a:t>
-            </a:r>
-            <a:endParaRPr lang="en-US" sz="1400" dirty="0"/>
-          </a:p>
-        </p:txBody>
-      </p:sp>
-      <p:sp>
-        <p:nvSpPr>
-          <p:cNvPr id="8" name="Text 5"/>
-          <p:cNvSpPr txBox="1"/>
-          <p:nvPr/>
-        </p:nvSpPr>
-        <p:spPr>
-          <a:xfrm>
-            <a:off x="640080" y="1965960"/>
-            <a:ext cx="2377440" cy="320040"/>
-          </a:xfrm>
-          <a:prstGeom prst="rect">
-            <a:avLst/>
-          </a:prstGeom>
-          <a:noFill/>
-          <a:ln/>
-        </p:spPr>
-        <p:txBody>
-          <a:bodyPr wrap="square" lIns="0" tIns="0" rIns="0" bIns="0" rtlCol="0" anchor="ctr"/>
-          <a:lstStyle/>
-          <a:p>
-            <a:pPr indent="0" marL="0">
-              <a:buNone/>
-            </a:pPr>
-            <a:r>
-              <a:rPr lang="en-US" sz="1050" b="1" dirty="0">
-                <a:solidFill>
-                  <a:srgbClr val="F5B341"/>
-                </a:solidFill>
-                <a:latin typeface="Courier New" pitchFamily="34" charset="0"/>
-                <a:ea typeface="Courier New" pitchFamily="34" charset="-122"/>
-                <a:cs typeface="Courier New" pitchFamily="34" charset="-120"/>
-              </a:rPr>
-              <a:t>rm -rf tests/ patches/ plan/ ~/</a:t>
-            </a:r>
-            <a:endParaRPr lang="en-US" sz="1050" dirty="0"/>
-          </a:p>
-        </p:txBody>
-      </p:sp>
-      <p:sp>
-        <p:nvSpPr>
-          <p:cNvPr id="9" name="Text 6"/>
-          <p:cNvSpPr txBox="1"/>
-          <p:nvPr/>
-        </p:nvSpPr>
-        <p:spPr>
-          <a:xfrm>
-            <a:off x="640080" y="2331720"/>
-            <a:ext cx="2377440" cy="1508760"/>
-          </a:xfrm>
-          <a:prstGeom prst="rect">
-            <a:avLst/>
-          </a:prstGeom>
-          <a:noFill/>
-          <a:ln/>
-        </p:spPr>
-        <p:txBody>
-          <a:bodyPr wrap="square" lIns="0" tIns="0" rIns="0" bIns="0" rtlCol="0" anchor="t"/>
-          <a:lstStyle/>
-          <a:p>
-            <a:pPr indent="0" marL="0">
-              <a:buNone/>
-            </a:pPr>
-            <a:r>
-              <a:rPr lang="en-US" sz="1000" dirty="0">
-                <a:solidFill>
-                  <a:srgbClr val="9FB0C8"/>
-                </a:solidFill>
-                <a:latin typeface="Calibri" pitchFamily="34" charset="0"/>
-                <a:ea typeface="Calibri" pitchFamily="34" charset="-122"/>
-                <a:cs typeface="Calibri" pitchFamily="34" charset="-120"/>
-              </a:rPr>
-              <a:t>Dec 2025, macOS: a cleanup task ended with the user's home directory. Mar 2026, Windows 11: Git Bash rm deleted files across C:\. Apr 2026, Windows, Accept-edits mode: parent folder removed, about 50 GB.</a:t>
-            </a:r>
-            <a:endParaRPr lang="en-US" sz="1000" dirty="0"/>
-          </a:p>
-        </p:txBody>
-      </p:sp>
-      <p:sp>
-        <p:nvSpPr>
-          <p:cNvPr id="10" name="Text 7"/>
-          <p:cNvSpPr txBox="1"/>
-          <p:nvPr/>
-        </p:nvSpPr>
-        <p:spPr>
-          <a:xfrm>
-            <a:off x="640080" y="3931920"/>
-            <a:ext cx="2377440" cy="594360"/>
-          </a:xfrm>
-          <a:prstGeom prst="rect">
-            <a:avLst/>
-          </a:prstGeom>
-          <a:noFill/>
-          <a:ln/>
-        </p:spPr>
-        <p:txBody>
-          <a:bodyPr wrap="square" lIns="0" tIns="0" rIns="0" bIns="0" rtlCol="0" anchor="t"/>
-          <a:lstStyle/>
-          <a:p>
-            <a:pPr indent="0" marL="0">
-              <a:buNone/>
-            </a:pPr>
-            <a:r>
-              <a:rPr lang="en-US" sz="1000" i="1" dirty="0">
-                <a:solidFill>
-                  <a:srgbClr val="EAF0FA"/>
-                </a:solidFill>
-                <a:latin typeface="Calibri" pitchFamily="34" charset="0"/>
-                <a:ea typeface="Calibri" pitchFamily="34" charset="-122"/>
-                <a:cs typeface="Calibri" pitchFamily="34" charset="-120"/>
-              </a:rPr>
-              <a:t>Policy checks read the command; the shell expanded ~ afterwards.</a:t>
-            </a:r>
-            <a:endParaRPr lang="en-US" sz="1000" dirty="0"/>
-          </a:p>
-        </p:txBody>
-      </p:sp>
-      <p:sp>
-        <p:nvSpPr>
-          <p:cNvPr id="11" name="Shape 8"/>
-          <p:cNvSpPr/>
-          <p:nvPr/>
-        </p:nvSpPr>
-        <p:spPr>
-          <a:xfrm>
-            <a:off x="3268980" y="1325880"/>
-            <a:ext cx="2697480" cy="3291840"/>
-          </a:xfrm>
-          <a:prstGeom prst="roundRect">
-            <a:avLst>
-              <a:gd name="adj" fmla="val 4068"/>
-            </a:avLst>
-          </a:prstGeom>
-          <a:solidFill>
-            <a:srgbClr val="141E33"/>
-          </a:solidFill>
-          <a:ln w="12700">
-            <a:solidFill>
-              <a:srgbClr val="2B3A57"/>
-            </a:solidFill>
-            <a:prstDash val="solid"/>
-          </a:ln>
-        </p:spPr>
-      </p:sp>
-      <p:sp>
-        <p:nvSpPr>
-          <p:cNvPr id="12" name="Shape 9"/>
-          <p:cNvSpPr/>
-          <p:nvPr/>
-        </p:nvSpPr>
-        <p:spPr>
-          <a:xfrm>
-            <a:off x="3451860" y="1463040"/>
-            <a:ext cx="384048" cy="384048"/>
-          </a:xfrm>
-          <a:prstGeom prst="ellipse">
-            <a:avLst/>
-          </a:prstGeom>
-          <a:solidFill>
-            <a:srgbClr val="5BA8FF"/>
-          </a:solidFill>
-          <a:ln w="12700">
-            <a:solidFill>
-              <a:srgbClr val="5BA8FF"/>
-            </a:solidFill>
-            <a:prstDash val="solid"/>
-          </a:ln>
-        </p:spPr>
-      </p:sp>
-      <p:pic>
-        <p:nvPicPr>
-          <p:cNvPr id="13" name="Image 1" descr="preencoded.png">    </p:cNvPr>
-          <p:cNvPicPr>
-            <a:picLocks noChangeAspect="1"/>
-          </p:cNvPicPr>
-          <p:nvPr/>
-        </p:nvPicPr>
-        <p:blipFill>
-          <a:blip r:embed="rId2"/>
-          <a:stretch>
-            <a:fillRect/>
-          </a:stretch>
-        </p:blipFill>
-        <p:spPr>
-          <a:xfrm>
-            <a:off x="3547872" y="1559052"/>
-            <a:ext cx="192024" cy="192024"/>
-          </a:xfrm>
-          <a:prstGeom prst="rect">
-            <a:avLst/>
-          </a:prstGeom>
-        </p:spPr>
-      </p:pic>
-      <p:sp>
-        <p:nvSpPr>
-          <p:cNvPr id="14" name="Text 10"/>
-          <p:cNvSpPr txBox="1"/>
-          <p:nvPr/>
-        </p:nvSpPr>
-        <p:spPr>
-          <a:xfrm>
-            <a:off x="3927348" y="1490472"/>
-            <a:ext cx="1920240" cy="320040"/>
-          </a:xfrm>
-          <a:prstGeom prst="rect">
-            <a:avLst/>
-          </a:prstGeom>
-          <a:noFill/>
-          <a:ln/>
-        </p:spPr>
-        <p:txBody>
-          <a:bodyPr wrap="square" lIns="0" tIns="0" rIns="0" bIns="0" rtlCol="0" anchor="ctr"/>
-          <a:lstStyle/>
-          <a:p>
-            <a:pPr indent="0" marL="0">
-              <a:buNone/>
-            </a:pPr>
-            <a:r>
-              <a:rPr lang="en-US" sz="1400" b="1" dirty="0">
-                <a:solidFill>
-                  <a:srgbClr val="EAF0FA"/>
-                </a:solidFill>
-                <a:latin typeface="Calibri" pitchFamily="34" charset="0"/>
-                <a:ea typeface="Calibri" pitchFamily="34" charset="-122"/>
-                <a:cs typeface="Calibri" pitchFamily="34" charset="-120"/>
-              </a:rPr>
-              <a:t>Codex</a:t>
-            </a:r>
-            <a:endParaRPr lang="en-US" sz="1400" dirty="0"/>
-          </a:p>
-        </p:txBody>
-      </p:sp>
-      <p:sp>
-        <p:nvSpPr>
-          <p:cNvPr id="15" name="Text 11"/>
-          <p:cNvSpPr txBox="1"/>
-          <p:nvPr/>
-        </p:nvSpPr>
-        <p:spPr>
-          <a:xfrm>
-            <a:off x="3451860" y="1965960"/>
-            <a:ext cx="2377440" cy="320040"/>
-          </a:xfrm>
-          <a:prstGeom prst="rect">
-            <a:avLst/>
-          </a:prstGeom>
-          <a:noFill/>
-          <a:ln/>
-        </p:spPr>
-        <p:txBody>
-          <a:bodyPr wrap="square" lIns="0" tIns="0" rIns="0" bIns="0" rtlCol="0" anchor="ctr"/>
-          <a:lstStyle/>
-          <a:p>
-            <a:pPr indent="0" marL="0">
-              <a:buNone/>
-            </a:pPr>
-            <a:r>
-              <a:rPr lang="en-US" sz="1050" b="1" dirty="0">
-                <a:solidFill>
-                  <a:srgbClr val="5BA8FF"/>
-                </a:solidFill>
-                <a:latin typeface="Courier New" pitchFamily="34" charset="0"/>
-                <a:ea typeface="Courier New" pitchFamily="34" charset="-122"/>
-                <a:cs typeface="Courier New" pitchFamily="34" charset="-120"/>
-              </a:rPr>
-              <a:t>Full access + approvals off</a:t>
-            </a:r>
-            <a:endParaRPr lang="en-US" sz="1050" dirty="0"/>
-          </a:p>
-        </p:txBody>
-      </p:sp>
-      <p:sp>
-        <p:nvSpPr>
-          <p:cNvPr id="16" name="Text 12"/>
-          <p:cNvSpPr txBox="1"/>
-          <p:nvPr/>
-        </p:nvSpPr>
-        <p:spPr>
-          <a:xfrm>
-            <a:off x="3451860" y="2331720"/>
-            <a:ext cx="2377440" cy="1508760"/>
-          </a:xfrm>
-          <a:prstGeom prst="rect">
-            <a:avLst/>
-          </a:prstGeom>
-          <a:noFill/>
-          <a:ln/>
-        </p:spPr>
-        <p:txBody>
-          <a:bodyPr wrap="square" lIns="0" tIns="0" rIns="0" bIns="0" rtlCol="0" anchor="t"/>
-          <a:lstStyle/>
-          <a:p>
-            <a:pPr indent="0" marL="0">
-              <a:buNone/>
-            </a:pPr>
-            <a:r>
-              <a:rPr lang="en-US" sz="1000" dirty="0">
-                <a:solidFill>
-                  <a:srgbClr val="9FB0C8"/>
-                </a:solidFill>
-                <a:latin typeface="Calibri" pitchFamily="34" charset="0"/>
-                <a:ea typeface="Calibri" pitchFamily="34" charset="-122"/>
-                <a:cs typeface="Calibri" pitchFamily="34" charset="-120"/>
-              </a:rPr>
-              <a:t>Apr 2026, Windows desktop app: a failed archive step deleted more than ten workspace roots under C:\src and folders under Program Files (x86). Jul 2026: recursive PowerShell delete wiped a repo including .git.</a:t>
-            </a:r>
-            <a:endParaRPr lang="en-US" sz="1000" dirty="0"/>
-          </a:p>
-        </p:txBody>
-      </p:sp>
-      <p:sp>
-        <p:nvSpPr>
-          <p:cNvPr id="17" name="Text 13"/>
-          <p:cNvSpPr txBox="1"/>
-          <p:nvPr/>
-        </p:nvSpPr>
-        <p:spPr>
-          <a:xfrm>
-            <a:off x="3451860" y="3931920"/>
-            <a:ext cx="2377440" cy="594360"/>
-          </a:xfrm>
-          <a:prstGeom prst="rect">
-            <a:avLst/>
-          </a:prstGeom>
-          <a:noFill/>
-          <a:ln/>
-        </p:spPr>
-        <p:txBody>
-          <a:bodyPr wrap="square" lIns="0" tIns="0" rIns="0" bIns="0" rtlCol="0" anchor="t"/>
-          <a:lstStyle/>
-          <a:p>
-            <a:pPr indent="0" marL="0">
-              <a:buNone/>
-            </a:pPr>
-            <a:r>
-              <a:rPr lang="en-US" sz="1000" i="1" dirty="0">
-                <a:solidFill>
-                  <a:srgbClr val="EAF0FA"/>
-                </a:solidFill>
-                <a:latin typeface="Calibri" pitchFamily="34" charset="0"/>
-                <a:ea typeface="Calibri" pitchFamily="34" charset="-122"/>
-                <a:cs typeface="Calibri" pitchFamily="34" charset="-120"/>
-              </a:rPr>
-              <a:t>No verified escape of Seatbelt or bubblewrap; the wall was switched off.</a:t>
-            </a:r>
-            <a:endParaRPr lang="en-US" sz="1000" dirty="0"/>
-          </a:p>
-        </p:txBody>
-      </p:sp>
-      <p:sp>
-        <p:nvSpPr>
-          <p:cNvPr id="18" name="Shape 14"/>
-          <p:cNvSpPr/>
-          <p:nvPr/>
-        </p:nvSpPr>
-        <p:spPr>
-          <a:xfrm>
-            <a:off x="6080760" y="1325880"/>
-            <a:ext cx="2697480" cy="3291840"/>
-          </a:xfrm>
-          <a:prstGeom prst="roundRect">
-            <a:avLst>
-              <a:gd name="adj" fmla="val 4068"/>
-            </a:avLst>
-          </a:prstGeom>
-          <a:solidFill>
-            <a:srgbClr val="141E33"/>
-          </a:solidFill>
-          <a:ln w="12700">
-            <a:solidFill>
-              <a:srgbClr val="2B3A57"/>
-            </a:solidFill>
-            <a:prstDash val="solid"/>
-          </a:ln>
-        </p:spPr>
-      </p:sp>
-      <p:sp>
-        <p:nvSpPr>
-          <p:cNvPr id="19" name="Shape 15"/>
-          <p:cNvSpPr/>
-          <p:nvPr/>
-        </p:nvSpPr>
-        <p:spPr>
-          <a:xfrm>
-            <a:off x="6263640" y="1463040"/>
-            <a:ext cx="384048" cy="384048"/>
-          </a:xfrm>
-          <a:prstGeom prst="ellipse">
-            <a:avLst/>
-          </a:prstGeom>
-          <a:solidFill>
-            <a:srgbClr val="FF6B6B"/>
-          </a:solidFill>
-          <a:ln w="12700">
-            <a:solidFill>
-              <a:srgbClr val="FF6B6B"/>
-            </a:solidFill>
-            <a:prstDash val="solid"/>
-          </a:ln>
-        </p:spPr>
-      </p:sp>
-      <p:pic>
-        <p:nvPicPr>
-          <p:cNvPr id="20" name="Image 2" descr="preencoded.png">    </p:cNvPr>
-          <p:cNvPicPr>
-            <a:picLocks noChangeAspect="1"/>
-          </p:cNvPicPr>
-          <p:nvPr/>
-        </p:nvPicPr>
-        <p:blipFill>
-          <a:blip r:embed="rId3"/>
-          <a:stretch>
-            <a:fillRect/>
-          </a:stretch>
-        </p:blipFill>
-        <p:spPr>
-          <a:xfrm>
-            <a:off x="6359652" y="1559052"/>
-            <a:ext cx="192024" cy="192024"/>
-          </a:xfrm>
-          <a:prstGeom prst="rect">
-            <a:avLst/>
-          </a:prstGeom>
-        </p:spPr>
-      </p:pic>
-      <p:sp>
-        <p:nvSpPr>
-          <p:cNvPr id="21" name="Text 16"/>
-          <p:cNvSpPr txBox="1"/>
-          <p:nvPr/>
-        </p:nvSpPr>
-        <p:spPr>
-          <a:xfrm>
-            <a:off x="6739128" y="1490472"/>
-            <a:ext cx="1920240" cy="320040"/>
-          </a:xfrm>
-          <a:prstGeom prst="rect">
-            <a:avLst/>
-          </a:prstGeom>
-          <a:noFill/>
-          <a:ln/>
-        </p:spPr>
-        <p:txBody>
-          <a:bodyPr wrap="square" lIns="0" tIns="0" rIns="0" bIns="0" rtlCol="0" anchor="ctr"/>
-          <a:lstStyle/>
-          <a:p>
-            <a:pPr indent="0" marL="0">
-              <a:buNone/>
-            </a:pPr>
-            <a:r>
-              <a:rPr lang="en-US" sz="1400" b="1" dirty="0">
-                <a:solidFill>
-                  <a:srgbClr val="EAF0FA"/>
-                </a:solidFill>
-                <a:latin typeface="Calibri" pitchFamily="34" charset="0"/>
-                <a:ea typeface="Calibri" pitchFamily="34" charset="-122"/>
-                <a:cs typeface="Calibri" pitchFamily="34" charset="-120"/>
-              </a:rPr>
-              <a:t>OpenCode</a:t>
-            </a:r>
-            <a:endParaRPr lang="en-US" sz="1400" dirty="0"/>
-          </a:p>
-        </p:txBody>
-      </p:sp>
-      <p:sp>
-        <p:nvSpPr>
-          <p:cNvPr id="22" name="Text 17"/>
-          <p:cNvSpPr txBox="1"/>
-          <p:nvPr/>
-        </p:nvSpPr>
-        <p:spPr>
-          <a:xfrm>
-            <a:off x="6263640" y="1965960"/>
-            <a:ext cx="2377440" cy="320040"/>
-          </a:xfrm>
-          <a:prstGeom prst="rect">
-            <a:avLst/>
-          </a:prstGeom>
-          <a:noFill/>
-          <a:ln/>
-        </p:spPr>
-        <p:txBody>
-          <a:bodyPr wrap="square" lIns="0" tIns="0" rIns="0" bIns="0" rtlCol="0" anchor="ctr"/>
-          <a:lstStyle/>
-          <a:p>
-            <a:pPr indent="0" marL="0">
-              <a:buNone/>
-            </a:pPr>
-            <a:r>
-              <a:rPr lang="en-US" sz="1050" b="1" dirty="0">
-                <a:solidFill>
-                  <a:srgbClr val="FF6B6B"/>
-                </a:solidFill>
-                <a:latin typeface="Courier New" pitchFamily="34" charset="0"/>
-                <a:ea typeface="Courier New" pitchFamily="34" charset="-122"/>
-                <a:cs typeface="Courier New" pitchFamily="34" charset="-120"/>
-              </a:rPr>
-              <a:t>"Everything on the E drive"</a:t>
-            </a:r>
-            <a:endParaRPr lang="en-US" sz="1050" dirty="0"/>
-          </a:p>
-        </p:txBody>
-      </p:sp>
-      <p:sp>
-        <p:nvSpPr>
-          <p:cNvPr id="23" name="Text 18"/>
-          <p:cNvSpPr txBox="1"/>
-          <p:nvPr/>
-        </p:nvSpPr>
-        <p:spPr>
-          <a:xfrm>
-            <a:off x="6263640" y="2331720"/>
-            <a:ext cx="2377440" cy="1508760"/>
-          </a:xfrm>
-          <a:prstGeom prst="rect">
-            <a:avLst/>
-          </a:prstGeom>
-          <a:noFill/>
-          <a:ln/>
-        </p:spPr>
-        <p:txBody>
-          <a:bodyPr wrap="square" lIns="0" tIns="0" rIns="0" bIns="0" rtlCol="0" anchor="t"/>
-          <a:lstStyle/>
-          <a:p>
-            <a:pPr indent="0" marL="0">
-              <a:buNone/>
-            </a:pPr>
-            <a:r>
-              <a:rPr lang="en-US" sz="1000" dirty="0">
-                <a:solidFill>
-                  <a:srgbClr val="9FB0C8"/>
-                </a:solidFill>
-                <a:latin typeface="Calibri" pitchFamily="34" charset="0"/>
-                <a:ea typeface="Calibri" pitchFamily="34" charset="-122"/>
-                <a:cs typeface="Calibri" pitchFamily="34" charset="-120"/>
-              </a:rPr>
-              <a:t>Jun 2026, v1.16: a cleanup task deleted a whole drive except files in use. Other reports: backups removed during broad cleanup tasks; symlink bypasses of the external-directory check, mostly fixed.</a:t>
-            </a:r>
-            <a:endParaRPr lang="en-US" sz="1000" dirty="0"/>
-          </a:p>
-        </p:txBody>
-      </p:sp>
-      <p:sp>
-        <p:nvSpPr>
-          <p:cNvPr id="24" name="Text 19"/>
-          <p:cNvSpPr txBox="1"/>
-          <p:nvPr/>
-        </p:nvSpPr>
-        <p:spPr>
-          <a:xfrm>
-            <a:off x="6263640" y="3931920"/>
-            <a:ext cx="2377440" cy="594360"/>
-          </a:xfrm>
-          <a:prstGeom prst="rect">
-            <a:avLst/>
-          </a:prstGeom>
-          <a:noFill/>
-          <a:ln/>
-        </p:spPr>
-        <p:txBody>
-          <a:bodyPr wrap="square" lIns="0" tIns="0" rIns="0" bIns="0" rtlCol="0" anchor="t"/>
-          <a:lstStyle/>
-          <a:p>
-            <a:pPr indent="0" marL="0">
-              <a:buNone/>
-            </a:pPr>
-            <a:r>
-              <a:rPr lang="en-US" sz="1000" i="1" dirty="0">
-                <a:solidFill>
-                  <a:srgbClr val="EAF0FA"/>
-                </a:solidFill>
-                <a:latin typeface="Calibri" pitchFamily="34" charset="0"/>
-                <a:ea typeface="Calibri" pitchFamily="34" charset="-122"/>
-                <a:cs typeface="Calibri" pitchFamily="34" charset="-120"/>
-              </a:rPr>
-              <a:t>No sandbox to escape; the prompt was the only barrier.</a:t>
-            </a:r>
-            <a:endParaRPr lang="en-US" sz="1000" dirty="0"/>
-          </a:p>
-        </p:txBody>
-      </p:sp>
-      <p:sp>
-        <p:nvSpPr>
-          <p:cNvPr id="25" name="Text 20"/>
-          <p:cNvSpPr txBox="1"/>
-          <p:nvPr/>
-        </p:nvSpPr>
-        <p:spPr>
-          <a:xfrm>
-            <a:off x="457200" y="4754880"/>
-            <a:ext cx="8229600" cy="274320"/>
-          </a:xfrm>
-          <a:prstGeom prst="rect">
-            <a:avLst/>
-          </a:prstGeom>
-          <a:noFill/>
-          <a:ln/>
-        </p:spPr>
-        <p:txBody>
-          <a:bodyPr wrap="square" lIns="0" tIns="0" rIns="0" bIns="0" rtlCol="0" anchor="ctr"/>
-          <a:lstStyle/>
-          <a:p>
-            <a:pPr indent="0" marL="0">
-              <a:buNone/>
-            </a:pPr>
-            <a:r>
-              <a:rPr lang="en-US" sz="900" dirty="0">
-                <a:solidFill>
-                  <a:srgbClr val="9FB0C8"/>
-                </a:solidFill>
-                <a:latin typeface="Calibri" pitchFamily="34" charset="0"/>
-                <a:ea typeface="Calibri" pitchFamily="34" charset="-122"/>
-                <a:cs typeface="Calibri" pitchFamily="34" charset="-120"/>
-              </a:rPr>
-              <a:t>Sources: anthropics/claude-code issues #33132, #49129; Docker blog; openai/codex issues #18509, #35707; anomalyco/opencode issues #31512, #33379, #7504</a:t>
-            </a:r>
-            <a:endParaRPr lang="en-US" sz="900" dirty="0"/>
-          </a:p>
-        </p:txBody>
-      </p:sp>
-    </p:spTree>
-  </p:cSld>
-  <p:clrMapOvr>
-    <a:masterClrMapping/>
-  </p:clrMapOvr>
-</p:sld>
-</file>
-
 <file path=ppt/slides/slide9.xml><?xml version="1.0" encoding="utf-8"?>
 <p:sld xmlns:a="http://schemas.openxmlformats.org/drawingml/2006/main" xmlns:r="http://schemas.openxmlformats.org/officeDocument/2006/relationships" xmlns:p="http://schemas.openxmlformats.org/presentationml/2006/main">
   <p:cSld name="Slide 9">
@@ -10244,7 +10899,7 @@
                 <a:ea typeface="Calibri" pitchFamily="34" charset="-122"/>
                 <a:cs typeface="Calibri" pitchFamily="34" charset="-120"/>
               </a:rPr>
-              <a:t>Recommendations for Windows users</a:t>
+              <a:t>It has happened with all three</a:t>
             </a:r>
             <a:endParaRPr lang="en-US" sz="2800" dirty="0"/>
           </a:p>
@@ -10283,7 +10938,7 @@
                 <a:ea typeface="Calibri" pitchFamily="34" charset="-122"/>
                 <a:cs typeface="Calibri" pitchFamily="34" charset="-120"/>
               </a:rPr>
-              <a:t>Get an enforced boundary, then tune the policy layer</a:t>
+              <a:t>Public reports of deletions outside the repository, 2025 to 2026</a:t>
             </a:r>
             <a:endParaRPr lang="en-US" sz="1300" dirty="0"/>
           </a:p>
@@ -10298,7 +10953,7 @@
         <p:spPr>
           <a:xfrm>
             <a:off x="457200" y="1325880"/>
-            <a:ext cx="2697480" cy="2743200"/>
+            <a:ext cx="2697480" cy="3291840"/>
           </a:xfrm>
           <a:prstGeom prst="roundRect">
             <a:avLst>
@@ -10325,7 +10980,7 @@
         <p:spPr>
           <a:xfrm>
             <a:off x="640080" y="1463040"/>
-            <a:ext cx="411480" cy="411480"/>
+            <a:ext cx="384048" cy="384048"/>
           </a:xfrm>
           <a:prstGeom prst="ellipse">
             <a:avLst/>
@@ -10357,8 +11012,8 @@
         </p:blipFill>
         <p:spPr>
           <a:xfrm>
-            <a:off x="742950" y="1565910"/>
-            <a:ext cx="205740" cy="205740"/>
+            <a:off x="736092" y="1559052"/>
+            <a:ext cx="192024" cy="192024"/>
           </a:xfrm>
           <a:prstGeom prst="rect">
             <a:avLst/>
@@ -10373,7 +11028,7 @@
         </p:nvSpPr>
         <p:spPr>
           <a:xfrm>
-            <a:off x="1143000" y="1508760"/>
+            <a:off x="1115568" y="1490472"/>
             <a:ext cx="1920240" cy="320040"/>
           </a:xfrm>
           <a:prstGeom prst="rect">
@@ -10398,7 +11053,7 @@
                 <a:ea typeface="Calibri" pitchFamily="34" charset="-122"/>
                 <a:cs typeface="Calibri" pitchFamily="34" charset="-120"/>
               </a:rPr>
-              <a:t>Claude Desktop</a:t>
+              <a:t>Claude Code</a:t>
             </a:r>
             <a:endParaRPr lang="en-US" sz="1400" dirty="0"/>
           </a:p>
@@ -10412,8 +11067,47 @@
         </p:nvSpPr>
         <p:spPr>
           <a:xfrm>
-            <a:off x="640080" y="2011680"/>
-            <a:ext cx="2377440" cy="1965960"/>
+            <a:off x="640080" y="1965960"/>
+            <a:ext cx="2377440" cy="320040"/>
+          </a:xfrm>
+          <a:prstGeom prst="rect">
+            <a:avLst/>
+          </a:prstGeom>
+          <a:noFill/>
+          <a:ln/>
+        </p:spPr>
+        <p:txBody>
+          <a:bodyPr wrap="square" lIns="0" tIns="0" rIns="0" bIns="0" rtlCol="0" anchor="ctr"/>
+          <a:lstStyle/>
+          <a:p>
+            <a:pPr indent="0" marL="0">
+              <a:buNone/>
+            </a:pPr>
+            <a:r>
+              <a:rPr lang="en-US" sz="1050" b="1" dirty="0">
+                <a:solidFill>
+                  <a:srgbClr val="F5B341"/>
+                </a:solidFill>
+                <a:latin typeface="Courier New" pitchFamily="34" charset="0"/>
+                <a:ea typeface="Courier New" pitchFamily="34" charset="-122"/>
+                <a:cs typeface="Courier New" pitchFamily="34" charset="-120"/>
+              </a:rPr>
+              <a:t>rm -rf tests/ patches/ plan/ ~/</a:t>
+            </a:r>
+            <a:endParaRPr lang="en-US" sz="1050" dirty="0"/>
+          </a:p>
+        </p:txBody>
+      </p:sp>
+      <p:sp>
+        <p:nvSpPr>
+          <p:cNvPr id="9" name="Text 6"/>
+          <p:cNvSpPr txBox="1"/>
+          <p:nvPr/>
+        </p:nvSpPr>
+        <p:spPr>
+          <a:xfrm>
+            <a:off x="640080" y="2331720"/>
+            <a:ext cx="2377440" cy="1508760"/>
           </a:xfrm>
           <a:prstGeom prst="rect">
             <a:avLst/>
@@ -10425,15 +11119,50 @@
           <a:bodyPr wrap="square" lIns="0" tIns="0" rIns="0" bIns="0" rtlCol="0" anchor="t"/>
           <a:lstStyle/>
           <a:p>
-            <a:pPr marL="152400" indent="-152400">
-              <a:spcAft>
-                <a:spcPts val="500"/>
-              </a:spcAft>
-              <a:buSzPct val="100000"/>
-              <a:buChar char="•"/>
+            <a:pPr indent="0" marL="0">
+              <a:buNone/>
             </a:pPr>
             <a:r>
-              <a:rPr lang="en-US" sz="1050" dirty="0">
+              <a:rPr lang="en-US" sz="1000" dirty="0">
+                <a:solidFill>
+                  <a:srgbClr val="9FB0C8"/>
+                </a:solidFill>
+                <a:latin typeface="Calibri" pitchFamily="34" charset="0"/>
+                <a:ea typeface="Calibri" pitchFamily="34" charset="-122"/>
+                <a:cs typeface="Calibri" pitchFamily="34" charset="-120"/>
+              </a:rPr>
+              <a:t>Dec 2025, macOS: a cleanup task ended with the user's home directory. Mar 2026, Windows 11: Git Bash rm deleted files across C:\. Apr 2026, Windows, Accept-edits mode: parent folder removed, about 50 GB.</a:t>
+            </a:r>
+            <a:endParaRPr lang="en-US" sz="1000" dirty="0"/>
+          </a:p>
+        </p:txBody>
+      </p:sp>
+      <p:sp>
+        <p:nvSpPr>
+          <p:cNvPr id="10" name="Text 7"/>
+          <p:cNvSpPr txBox="1"/>
+          <p:nvPr/>
+        </p:nvSpPr>
+        <p:spPr>
+          <a:xfrm>
+            <a:off x="640080" y="3931920"/>
+            <a:ext cx="2377440" cy="594360"/>
+          </a:xfrm>
+          <a:prstGeom prst="rect">
+            <a:avLst/>
+          </a:prstGeom>
+          <a:noFill/>
+          <a:ln/>
+        </p:spPr>
+        <p:txBody>
+          <a:bodyPr wrap="square" lIns="0" tIns="0" rIns="0" bIns="0" rtlCol="0" anchor="t"/>
+          <a:lstStyle/>
+          <a:p>
+            <a:pPr indent="0" marL="0">
+              <a:buNone/>
+            </a:pPr>
+            <a:r>
+              <a:rPr lang="en-US" sz="1000" i="1" dirty="0">
                 <a:solidFill>
                   <a:srgbClr val="EAF0FA"/>
                 </a:solidFill>
@@ -10441,64 +11170,22 @@
                 <a:ea typeface="Calibri" pitchFamily="34" charset="-122"/>
                 <a:cs typeface="Calibri" pitchFamily="34" charset="-120"/>
               </a:rPr>
-              <a:t>Start sessions in the WSL environment and run /sandbox once; keep denyRead on ~/.ssh and ~/.aws.</a:t>
-            </a:r>
-            <a:endParaRPr lang="en-US" sz="1050" dirty="0"/>
-          </a:p>
-          <a:p>
-            <a:pPr marL="152400" indent="-152400">
-              <a:spcAft>
-                <a:spcPts val="500"/>
-              </a:spcAft>
-              <a:buSzPct val="100000"/>
-              <a:buChar char="•"/>
-            </a:pPr>
-            <a:r>
-              <a:rPr lang="en-US" sz="1050" dirty="0">
-                <a:solidFill>
-                  <a:srgbClr val="EAF0FA"/>
-                </a:solidFill>
-                <a:latin typeface="Calibri" pitchFamily="34" charset="0"/>
-                <a:ea typeface="Calibri" pitchFamily="34" charset="-122"/>
-                <a:cs typeface="Calibri" pitchFamily="34" charset="-120"/>
-              </a:rPr>
-              <a:t>For untrusted repos use a Cloud session; never enable Bypass on the host.</a:t>
-            </a:r>
-            <a:endParaRPr lang="en-US" sz="1050" dirty="0"/>
-          </a:p>
-          <a:p>
-            <a:pPr marL="152400" indent="-152400">
-              <a:spcAft>
-                <a:spcPts val="500"/>
-              </a:spcAft>
-              <a:buSzPct val="100000"/>
-              <a:buChar char="•"/>
-            </a:pPr>
-            <a:r>
-              <a:rPr lang="en-US" sz="1050" dirty="0">
-                <a:solidFill>
-                  <a:srgbClr val="EAF0FA"/>
-                </a:solidFill>
-                <a:latin typeface="Calibri" pitchFamily="34" charset="0"/>
-                <a:ea typeface="Calibri" pitchFamily="34" charset="-122"/>
-                <a:cs typeface="Calibri" pitchFamily="34" charset="-120"/>
-              </a:rPr>
-              <a:t>Keep Auto or Manual; add deny rules for rm -rf and curl | bash in settings.</a:t>
-            </a:r>
-            <a:endParaRPr lang="en-US" sz="1050" dirty="0"/>
+              <a:t>Policy checks read the command; the shell expanded ~ afterwards.</a:t>
+            </a:r>
+            <a:endParaRPr lang="en-US" sz="1000" dirty="0"/>
           </a:p>
         </p:txBody>
       </p:sp>
       <p:sp>
         <p:nvSpPr>
-          <p:cNvPr id="9" name="Shape 6"/>
+          <p:cNvPr id="11" name="Shape 8"/>
           <p:cNvSpPr/>
           <p:nvPr/>
         </p:nvSpPr>
         <p:spPr>
           <a:xfrm>
             <a:off x="3268980" y="1325880"/>
-            <a:ext cx="2697480" cy="2743200"/>
+            <a:ext cx="2697480" cy="3291840"/>
           </a:xfrm>
           <a:prstGeom prst="roundRect">
             <a:avLst>
@@ -10518,14 +11205,14 @@
       </p:sp>
       <p:sp>
         <p:nvSpPr>
-          <p:cNvPr id="10" name="Shape 7"/>
+          <p:cNvPr id="12" name="Shape 9"/>
           <p:cNvSpPr/>
           <p:nvPr/>
         </p:nvSpPr>
         <p:spPr>
           <a:xfrm>
             <a:off x="3451860" y="1463040"/>
-            <a:ext cx="411480" cy="411480"/>
+            <a:ext cx="384048" cy="384048"/>
           </a:xfrm>
           <a:prstGeom prst="ellipse">
             <a:avLst/>
@@ -10543,7 +11230,7 @@
       </p:sp>
       <p:pic>
         <p:nvPicPr>
-          <p:cNvPr id="11" name="Image 1" descr="preencoded.png">    </p:cNvPr>
+          <p:cNvPr id="13" name="Image 1" descr="preencoded.png">    </p:cNvPr>
           <p:cNvPicPr>
             <a:picLocks noChangeAspect="1"/>
           </p:cNvPicPr>
@@ -10557,8 +11244,8 @@
         </p:blipFill>
         <p:spPr>
           <a:xfrm>
-            <a:off x="3554730" y="1565910"/>
-            <a:ext cx="205740" cy="205740"/>
+            <a:off x="3547872" y="1559052"/>
+            <a:ext cx="192024" cy="192024"/>
           </a:xfrm>
           <a:prstGeom prst="rect">
             <a:avLst/>
@@ -10567,13 +11254,13 @@
       </p:pic>
       <p:sp>
         <p:nvSpPr>
-          <p:cNvPr id="12" name="Text 8"/>
+          <p:cNvPr id="14" name="Text 10"/>
           <p:cNvSpPr txBox="1"/>
           <p:nvPr/>
         </p:nvSpPr>
         <p:spPr>
           <a:xfrm>
-            <a:off x="3954780" y="1508760"/>
+            <a:off x="3927348" y="1490472"/>
             <a:ext cx="1920240" cy="320040"/>
           </a:xfrm>
           <a:prstGeom prst="rect">
@@ -10598,7 +11285,7 @@
                 <a:ea typeface="Calibri" pitchFamily="34" charset="-122"/>
                 <a:cs typeface="Calibri" pitchFamily="34" charset="-120"/>
               </a:rPr>
-              <a:t>ChatGPT / Codex</a:t>
+              <a:t>Codex</a:t>
             </a:r>
             <a:endParaRPr lang="en-US" sz="1400" dirty="0"/>
           </a:p>
@@ -10606,14 +11293,53 @@
       </p:sp>
       <p:sp>
         <p:nvSpPr>
-          <p:cNvPr id="13" name="Text 9"/>
+          <p:cNvPr id="15" name="Text 11"/>
           <p:cNvSpPr txBox="1"/>
           <p:nvPr/>
         </p:nvSpPr>
         <p:spPr>
           <a:xfrm>
-            <a:off x="3451860" y="2011680"/>
-            <a:ext cx="2377440" cy="1965960"/>
+            <a:off x="3451860" y="1965960"/>
+            <a:ext cx="2377440" cy="320040"/>
+          </a:xfrm>
+          <a:prstGeom prst="rect">
+            <a:avLst/>
+          </a:prstGeom>
+          <a:noFill/>
+          <a:ln/>
+        </p:spPr>
+        <p:txBody>
+          <a:bodyPr wrap="square" lIns="0" tIns="0" rIns="0" bIns="0" rtlCol="0" anchor="ctr"/>
+          <a:lstStyle/>
+          <a:p>
+            <a:pPr indent="0" marL="0">
+              <a:buNone/>
+            </a:pPr>
+            <a:r>
+              <a:rPr lang="en-US" sz="1050" b="1" dirty="0">
+                <a:solidFill>
+                  <a:srgbClr val="5BA8FF"/>
+                </a:solidFill>
+                <a:latin typeface="Courier New" pitchFamily="34" charset="0"/>
+                <a:ea typeface="Courier New" pitchFamily="34" charset="-122"/>
+                <a:cs typeface="Courier New" pitchFamily="34" charset="-120"/>
+              </a:rPr>
+              <a:t>Full access + approvals off</a:t>
+            </a:r>
+            <a:endParaRPr lang="en-US" sz="1050" dirty="0"/>
+          </a:p>
+        </p:txBody>
+      </p:sp>
+      <p:sp>
+        <p:nvSpPr>
+          <p:cNvPr id="16" name="Text 12"/>
+          <p:cNvSpPr txBox="1"/>
+          <p:nvPr/>
+        </p:nvSpPr>
+        <p:spPr>
+          <a:xfrm>
+            <a:off x="3451860" y="2331720"/>
+            <a:ext cx="2377440" cy="1508760"/>
           </a:xfrm>
           <a:prstGeom prst="rect">
             <a:avLst/>
@@ -10625,15 +11351,50 @@
           <a:bodyPr wrap="square" lIns="0" tIns="0" rIns="0" bIns="0" rtlCol="0" anchor="t"/>
           <a:lstStyle/>
           <a:p>
-            <a:pPr marL="152400" indent="-152400">
-              <a:spcAft>
-                <a:spcPts val="500"/>
-              </a:spcAft>
-              <a:buSzPct val="100000"/>
-              <a:buChar char="•"/>
+            <a:pPr indent="0" marL="0">
+              <a:buNone/>
             </a:pPr>
             <a:r>
-              <a:rPr lang="en-US" sz="1050" dirty="0">
+              <a:rPr lang="en-US" sz="1000" dirty="0">
+                <a:solidFill>
+                  <a:srgbClr val="9FB0C8"/>
+                </a:solidFill>
+                <a:latin typeface="Calibri" pitchFamily="34" charset="0"/>
+                <a:ea typeface="Calibri" pitchFamily="34" charset="-122"/>
+                <a:cs typeface="Calibri" pitchFamily="34" charset="-120"/>
+              </a:rPr>
+              <a:t>Apr 2026, Windows desktop app: a failed archive step deleted more than ten workspace roots under C:\src and folders under Program Files (x86). Jul 2026: recursive PowerShell delete wiped a repo including .git.</a:t>
+            </a:r>
+            <a:endParaRPr lang="en-US" sz="1000" dirty="0"/>
+          </a:p>
+        </p:txBody>
+      </p:sp>
+      <p:sp>
+        <p:nvSpPr>
+          <p:cNvPr id="17" name="Text 13"/>
+          <p:cNvSpPr txBox="1"/>
+          <p:nvPr/>
+        </p:nvSpPr>
+        <p:spPr>
+          <a:xfrm>
+            <a:off x="3451860" y="3931920"/>
+            <a:ext cx="2377440" cy="594360"/>
+          </a:xfrm>
+          <a:prstGeom prst="rect">
+            <a:avLst/>
+          </a:prstGeom>
+          <a:noFill/>
+          <a:ln/>
+        </p:spPr>
+        <p:txBody>
+          <a:bodyPr wrap="square" lIns="0" tIns="0" rIns="0" bIns="0" rtlCol="0" anchor="t"/>
+          <a:lstStyle/>
+          <a:p>
+            <a:pPr indent="0" marL="0">
+              <a:buNone/>
+            </a:pPr>
+            <a:r>
+              <a:rPr lang="en-US" sz="1000" i="1" dirty="0">
                 <a:solidFill>
                   <a:srgbClr val="EAF0FA"/>
                 </a:solidFill>
@@ -10641,64 +11402,22 @@
                 <a:ea typeface="Calibri" pitchFamily="34" charset="-122"/>
                 <a:cs typeface="Calibri" pitchFamily="34" charset="-120"/>
               </a:rPr>
-              <a:t>Install the elevated Windows sandbox (admin once) or run under WSL 2.</a:t>
-            </a:r>
-            <a:endParaRPr lang="en-US" sz="1050" dirty="0"/>
-          </a:p>
-          <a:p>
-            <a:pPr marL="152400" indent="-152400">
-              <a:spcAft>
-                <a:spcPts val="500"/>
-              </a:spcAft>
-              <a:buSzPct val="100000"/>
-              <a:buChar char="•"/>
-            </a:pPr>
-            <a:r>
-              <a:rPr lang="en-US" sz="1050" dirty="0">
-                <a:solidFill>
-                  <a:srgbClr val="EAF0FA"/>
-                </a:solidFill>
-                <a:latin typeface="Calibri" pitchFamily="34" charset="0"/>
-                <a:ea typeface="Calibri" pitchFamily="34" charset="-122"/>
-                <a:cs typeface="Calibri" pitchFamily="34" charset="-120"/>
-              </a:rPr>
-              <a:t>Stay in Auto (workspace-write, network off). Treat every "run outside sandbox" approval as a Full-access moment.</a:t>
-            </a:r>
-            <a:endParaRPr lang="en-US" sz="1050" dirty="0"/>
-          </a:p>
-          <a:p>
-            <a:pPr marL="152400" indent="-152400">
-              <a:spcAft>
-                <a:spcPts val="500"/>
-              </a:spcAft>
-              <a:buSzPct val="100000"/>
-              <a:buChar char="•"/>
-            </a:pPr>
-            <a:r>
-              <a:rPr lang="en-US" sz="1050" dirty="0">
-                <a:solidFill>
-                  <a:srgbClr val="EAF0FA"/>
-                </a:solidFill>
-                <a:latin typeface="Calibri" pitchFamily="34" charset="0"/>
-                <a:ea typeface="Calibri" pitchFamily="34" charset="-122"/>
-                <a:cs typeface="Calibri" pitchFamily="34" charset="-120"/>
-              </a:rPr>
-              <a:t>Never use Full access outside a disposable container.</a:t>
-            </a:r>
-            <a:endParaRPr lang="en-US" sz="1050" dirty="0"/>
+              <a:t>No verified escape of Seatbelt or bubblewrap; the wall was switched off.</a:t>
+            </a:r>
+            <a:endParaRPr lang="en-US" sz="1000" dirty="0"/>
           </a:p>
         </p:txBody>
       </p:sp>
       <p:sp>
         <p:nvSpPr>
-          <p:cNvPr id="14" name="Shape 10"/>
+          <p:cNvPr id="18" name="Shape 14"/>
           <p:cNvSpPr/>
           <p:nvPr/>
         </p:nvSpPr>
         <p:spPr>
           <a:xfrm>
             <a:off x="6080760" y="1325880"/>
-            <a:ext cx="2697480" cy="2743200"/>
+            <a:ext cx="2697480" cy="3291840"/>
           </a:xfrm>
           <a:prstGeom prst="roundRect">
             <a:avLst>
@@ -10718,24 +11437,24 @@
       </p:sp>
       <p:sp>
         <p:nvSpPr>
-          <p:cNvPr id="15" name="Shape 11"/>
+          <p:cNvPr id="19" name="Shape 15"/>
           <p:cNvSpPr/>
           <p:nvPr/>
         </p:nvSpPr>
         <p:spPr>
           <a:xfrm>
             <a:off x="6263640" y="1463040"/>
-            <a:ext cx="411480" cy="411480"/>
+            <a:ext cx="384048" cy="384048"/>
           </a:xfrm>
           <a:prstGeom prst="ellipse">
             <a:avLst/>
           </a:prstGeom>
           <a:solidFill>
-            <a:srgbClr val="3DD68C"/>
+            <a:srgbClr val="FF6B6B"/>
           </a:solidFill>
           <a:ln w="12700">
             <a:solidFill>
-              <a:srgbClr val="3DD68C"/>
+              <a:srgbClr val="FF6B6B"/>
             </a:solidFill>
             <a:prstDash val="solid"/>
           </a:ln>
@@ -10743,7 +11462,7 @@
       </p:sp>
       <p:pic>
         <p:nvPicPr>
-          <p:cNvPr id="16" name="Image 2" descr="preencoded.png">    </p:cNvPr>
+          <p:cNvPr id="20" name="Image 2" descr="preencoded.png">    </p:cNvPr>
           <p:cNvPicPr>
             <a:picLocks noChangeAspect="1"/>
           </p:cNvPicPr>
@@ -10757,8 +11476,8 @@
         </p:blipFill>
         <p:spPr>
           <a:xfrm>
-            <a:off x="6366510" y="1565910"/>
-            <a:ext cx="205740" cy="205740"/>
+            <a:off x="6359652" y="1559052"/>
+            <a:ext cx="192024" cy="192024"/>
           </a:xfrm>
           <a:prstGeom prst="rect">
             <a:avLst/>
@@ -10767,13 +11486,13 @@
       </p:pic>
       <p:sp>
         <p:nvSpPr>
-          <p:cNvPr id="17" name="Text 12"/>
+          <p:cNvPr id="21" name="Text 16"/>
           <p:cNvSpPr txBox="1"/>
           <p:nvPr/>
         </p:nvSpPr>
         <p:spPr>
           <a:xfrm>
-            <a:off x="6766560" y="1508760"/>
+            <a:off x="6739128" y="1490472"/>
             <a:ext cx="1920240" cy="320040"/>
           </a:xfrm>
           <a:prstGeom prst="rect">
@@ -10798,7 +11517,7 @@
                 <a:ea typeface="Calibri" pitchFamily="34" charset="-122"/>
                 <a:cs typeface="Calibri" pitchFamily="34" charset="-120"/>
               </a:rPr>
-              <a:t>OpenCode Desktop</a:t>
+              <a:t>OpenCode</a:t>
             </a:r>
             <a:endParaRPr lang="en-US" sz="1400" dirty="0"/>
           </a:p>
@@ -10806,14 +11525,53 @@
       </p:sp>
       <p:sp>
         <p:nvSpPr>
-          <p:cNvPr id="18" name="Text 13"/>
+          <p:cNvPr id="22" name="Text 17"/>
           <p:cNvSpPr txBox="1"/>
           <p:nvPr/>
         </p:nvSpPr>
         <p:spPr>
           <a:xfrm>
-            <a:off x="6263640" y="2011680"/>
-            <a:ext cx="2377440" cy="1965960"/>
+            <a:off x="6263640" y="1965960"/>
+            <a:ext cx="2377440" cy="320040"/>
+          </a:xfrm>
+          <a:prstGeom prst="rect">
+            <a:avLst/>
+          </a:prstGeom>
+          <a:noFill/>
+          <a:ln/>
+        </p:spPr>
+        <p:txBody>
+          <a:bodyPr wrap="square" lIns="0" tIns="0" rIns="0" bIns="0" rtlCol="0" anchor="ctr"/>
+          <a:lstStyle/>
+          <a:p>
+            <a:pPr indent="0" marL="0">
+              <a:buNone/>
+            </a:pPr>
+            <a:r>
+              <a:rPr lang="en-US" sz="1050" b="1" dirty="0">
+                <a:solidFill>
+                  <a:srgbClr val="FF6B6B"/>
+                </a:solidFill>
+                <a:latin typeface="Courier New" pitchFamily="34" charset="0"/>
+                <a:ea typeface="Courier New" pitchFamily="34" charset="-122"/>
+                <a:cs typeface="Courier New" pitchFamily="34" charset="-120"/>
+              </a:rPr>
+              <a:t>"Everything on the E drive"</a:t>
+            </a:r>
+            <a:endParaRPr lang="en-US" sz="1050" dirty="0"/>
+          </a:p>
+        </p:txBody>
+      </p:sp>
+      <p:sp>
+        <p:nvSpPr>
+          <p:cNvPr id="23" name="Text 18"/>
+          <p:cNvSpPr txBox="1"/>
+          <p:nvPr/>
+        </p:nvSpPr>
+        <p:spPr>
+          <a:xfrm>
+            <a:off x="6263640" y="2331720"/>
+            <a:ext cx="2377440" cy="1508760"/>
           </a:xfrm>
           <a:prstGeom prst="rect">
             <a:avLst/>
@@ -10825,15 +11583,50 @@
           <a:bodyPr wrap="square" lIns="0" tIns="0" rIns="0" bIns="0" rtlCol="0" anchor="t"/>
           <a:lstStyle/>
           <a:p>
-            <a:pPr marL="152400" indent="-152400">
-              <a:spcAft>
-                <a:spcPts val="500"/>
-              </a:spcAft>
-              <a:buSzPct val="100000"/>
-              <a:buChar char="•"/>
+            <a:pPr indent="0" marL="0">
+              <a:buNone/>
             </a:pPr>
             <a:r>
-              <a:rPr lang="en-US" sz="1050" dirty="0">
+              <a:rPr lang="en-US" sz="1000" dirty="0">
+                <a:solidFill>
+                  <a:srgbClr val="9FB0C8"/>
+                </a:solidFill>
+                <a:latin typeface="Calibri" pitchFamily="34" charset="0"/>
+                <a:ea typeface="Calibri" pitchFamily="34" charset="-122"/>
+                <a:cs typeface="Calibri" pitchFamily="34" charset="-120"/>
+              </a:rPr>
+              <a:t>Jun 2026, v1.16: a cleanup task deleted a whole drive except files in use. Other reports: backups removed during broad cleanup tasks; symlink bypasses of the external-directory check, mostly fixed.</a:t>
+            </a:r>
+            <a:endParaRPr lang="en-US" sz="1000" dirty="0"/>
+          </a:p>
+        </p:txBody>
+      </p:sp>
+      <p:sp>
+        <p:nvSpPr>
+          <p:cNvPr id="24" name="Text 19"/>
+          <p:cNvSpPr txBox="1"/>
+          <p:nvPr/>
+        </p:nvSpPr>
+        <p:spPr>
+          <a:xfrm>
+            <a:off x="6263640" y="3931920"/>
+            <a:ext cx="2377440" cy="594360"/>
+          </a:xfrm>
+          <a:prstGeom prst="rect">
+            <a:avLst/>
+          </a:prstGeom>
+          <a:noFill/>
+          <a:ln/>
+        </p:spPr>
+        <p:txBody>
+          <a:bodyPr wrap="square" lIns="0" tIns="0" rIns="0" bIns="0" rtlCol="0" anchor="t"/>
+          <a:lstStyle/>
+          <a:p>
+            <a:pPr indent="0" marL="0">
+              <a:buNone/>
+            </a:pPr>
+            <a:r>
+              <a:rPr lang="en-US" sz="1000" i="1" dirty="0">
                 <a:solidFill>
                   <a:srgbClr val="EAF0FA"/>
                 </a:solidFill>
@@ -10841,117 +11634,48 @@
                 <a:ea typeface="Calibri" pitchFamily="34" charset="-122"/>
                 <a:cs typeface="Calibri" pitchFamily="34" charset="-120"/>
               </a:rPr>
-              <a:t>Run it inside Docker Sandboxes, a dev container or a VM; the app itself has no wall.</a:t>
-            </a:r>
-            <a:endParaRPr lang="en-US" sz="1050" dirty="0"/>
-          </a:p>
-          <a:p>
-            <a:pPr marL="152400" indent="-152400">
-              <a:spcAft>
-                <a:spcPts val="500"/>
-              </a:spcAft>
-              <a:buSzPct val="100000"/>
-              <a:buChar char="•"/>
+              <a:t>No sandbox to escape; the prompt was the only barrier.</a:t>
+            </a:r>
+            <a:endParaRPr lang="en-US" sz="1000" dirty="0"/>
+          </a:p>
+        </p:txBody>
+      </p:sp>
+      <p:sp>
+        <p:nvSpPr>
+          <p:cNvPr id="25" name="Text 20"/>
+          <p:cNvSpPr txBox="1"/>
+          <p:nvPr/>
+        </p:nvSpPr>
+        <p:spPr>
+          <a:xfrm>
+            <a:off x="457200" y="4754880"/>
+            <a:ext cx="8229600" cy="274320"/>
+          </a:xfrm>
+          <a:prstGeom prst="rect">
+            <a:avLst/>
+          </a:prstGeom>
+          <a:noFill/>
+          <a:ln/>
+        </p:spPr>
+        <p:txBody>
+          <a:bodyPr wrap="square" lIns="0" tIns="0" rIns="0" bIns="0" rtlCol="0" anchor="ctr"/>
+          <a:lstStyle/>
+          <a:p>
+            <a:pPr indent="0" marL="0">
+              <a:buNone/>
             </a:pPr>
             <a:r>
-              <a:rPr lang="en-US" sz="1050" dirty="0">
+              <a:rPr lang="en-US" sz="900" dirty="0">
                 <a:solidFill>
-                  <a:srgbClr val="EAF0FA"/>
+                  <a:srgbClr val="9FB0C8"/>
                 </a:solidFill>
                 <a:latin typeface="Calibri" pitchFamily="34" charset="0"/>
                 <a:ea typeface="Calibri" pitchFamily="34" charset="-122"/>
                 <a:cs typeface="Calibri" pitchFamily="34" charset="-120"/>
               </a:rPr>
-              <a:t>Set bash and edit to "ask" for the build agent; deny rm *, format, and git push --force.</a:t>
-            </a:r>
-            <a:endParaRPr lang="en-US" sz="1050" dirty="0"/>
-          </a:p>
-          <a:p>
-            <a:pPr marL="152400" indent="-152400">
-              <a:spcAft>
-                <a:spcPts val="500"/>
-              </a:spcAft>
-              <a:buSzPct val="100000"/>
-              <a:buChar char="•"/>
-            </a:pPr>
-            <a:r>
-              <a:rPr lang="en-US" sz="1050" dirty="0">
-                <a:solidFill>
-                  <a:srgbClr val="EAF0FA"/>
-                </a:solidFill>
-                <a:latin typeface="Calibri" pitchFamily="34" charset="0"/>
-                <a:ea typeface="Calibri" pitchFamily="34" charset="-122"/>
-                <a:cs typeface="Calibri" pitchFamily="34" charset="-120"/>
-              </a:rPr>
-              <a:t>Set share to disabled; protect auth.json.</a:t>
-            </a:r>
-            <a:endParaRPr lang="en-US" sz="1050" dirty="0"/>
-          </a:p>
-        </p:txBody>
-      </p:sp>
-      <p:sp>
-        <p:nvSpPr>
-          <p:cNvPr id="19" name="Shape 14"/>
-          <p:cNvSpPr/>
-          <p:nvPr/>
-        </p:nvSpPr>
-        <p:spPr>
-          <a:xfrm>
-            <a:off x="457200" y="4206240"/>
-            <a:ext cx="8229600" cy="502920"/>
-          </a:xfrm>
-          <a:prstGeom prst="roundRect">
-            <a:avLst>
-              <a:gd name="adj" fmla="val 18182"/>
-            </a:avLst>
-          </a:prstGeom>
-          <a:solidFill>
-            <a:srgbClr val="F5B341"/>
-          </a:solidFill>
-          <a:ln w="12700">
-            <a:solidFill>
-              <a:srgbClr val="F5B341"/>
-            </a:solidFill>
-            <a:prstDash val="solid"/>
-          </a:ln>
-        </p:spPr>
-      </p:sp>
-      <p:sp>
-        <p:nvSpPr>
-          <p:cNvPr id="20" name="Text 15"/>
-          <p:cNvSpPr txBox="1"/>
-          <p:nvPr/>
-        </p:nvSpPr>
-        <p:spPr>
-          <a:xfrm>
-            <a:off x="640080" y="4206240"/>
-            <a:ext cx="7863840" cy="502920"/>
-          </a:xfrm>
-          <a:prstGeom prst="rect">
-            <a:avLst/>
-          </a:prstGeom>
-          <a:noFill/>
-          <a:ln/>
-        </p:spPr>
-        <p:txBody>
-          <a:bodyPr wrap="square" lIns="0" tIns="0" rIns="0" bIns="0" rtlCol="0" anchor="ctr"/>
-          <a:lstStyle/>
-          <a:p>
-            <a:pPr indent="0" marL="0">
-              <a:buNone/>
-            </a:pPr>
-            <a:r>
-              <a:rPr lang="en-US" sz="1300" b="1" dirty="0">
-                <a:solidFill>
-                  <a:srgbClr val="0B1220"/>
-                </a:solidFill>
-                <a:latin typeface="Calibri" pitchFamily="34" charset="0"/>
-                <a:ea typeface="Calibri" pitchFamily="34" charset="-122"/>
-                <a:cs typeface="Calibri" pitchFamily="34" charset="-120"/>
-              </a:rPr>
-              <a:t>For all three: commit before you start, keep backups outside the machine, and never run an agent in your home directory.</a:t>
-            </a:r>
-            <a:endParaRPr lang="en-US" sz="1300" dirty="0"/>
+              <a:t>Sources: anthropics/claude-code issues #33132, #49129; Docker blog; openai/codex issues #18509, #35707; anomalyco/opencode issues #31512, #33379, #7504</a:t>
+            </a:r>
+            <a:endParaRPr lang="en-US" sz="900" dirty="0"/>
           </a:p>
         </p:txBody>
       </p:sp>

</xml_diff>